<commit_message>
Deck: against-the-brief slide (Track 3 asks + scoring)
Co-Authored-By: Claude Fable 5.1 <noreply@anthropic.com>
</commit_message>
<xml_diff>
--- a/docs/Doorman-deck.pptx
+++ b/docs/Doorman-deck.pptx
@@ -12,9 +12,10 @@
     <p:sldId id="260" r:id="rId6"/>
     <p:sldId id="261" r:id="rId7"/>
     <p:sldId id="262" r:id="rId8"/>
+    <p:sldId id="263" r:id="rId9"/>
   </p:sldIdLst>
   <p:notesMasterIdLst>
-    <p:notesMasterId r:id="rId9"/>
+    <p:notesMasterId r:id="rId10"/>
   </p:notesMasterIdLst>
   <p:sldSz cx="12192000" cy="6858000"/>
   <p:notesSz cx="6858000" cy="12192000"/>
@@ -1060,6 +1061,94 @@
             <a:fld id="{F7021451-1387-4CA6-816F-3879F97B5CBC}" type="slidenum">
               <a:rPr lang="en-US"/>
               <a:t>7</a:t>
+            </a:fld>
+            <a:endParaRPr lang="en-US"/>
+          </a:p>
+        </p:txBody>
+      </p:sp>
+    </p:spTree>
+    <p:extLst>
+      <p:ext uri="{BB962C8B-B14F-4D97-AF65-F5344CB8AC3E}">
+        <p14:creationId xmlns:p14="http://schemas.microsoft.com/office/powerpoint/2010/main" val="1024086991"/>
+      </p:ext>
+    </p:extLst>
+  </p:cSld>
+  <p:clrMapOvr>
+    <a:masterClrMapping/>
+  </p:clrMapOvr>
+</p:notes>
+</file>
+
+<file path=ppt/notesSlides/notesSlide8.xml><?xml version="1.0" encoding="utf-8"?>
+<p:notes xmlns:a="http://schemas.openxmlformats.org/drawingml/2006/main" xmlns:r="http://schemas.openxmlformats.org/officeDocument/2006/relationships" xmlns:p="http://schemas.openxmlformats.org/presentationml/2006/main">
+  <p:cSld>
+    <p:spTree>
+      <p:nvGrpSpPr>
+        <p:cNvPr id="1" name=""/>
+        <p:cNvGrpSpPr/>
+        <p:nvPr/>
+      </p:nvGrpSpPr>
+      <p:grpSpPr>
+        <a:xfrm>
+          <a:off x="0" y="0"/>
+          <a:ext cx="0" cy="0"/>
+          <a:chOff x="0" y="0"/>
+          <a:chExt cx="0" cy="0"/>
+        </a:xfrm>
+      </p:grpSpPr>
+      <p:sp>
+        <p:nvSpPr>
+          <p:cNvPr id="2" name="Slide Image Placeholder 1"/>
+          <p:cNvSpPr>
+            <a:spLocks noGrp="1" noRot="1" noChangeAspect="1"/>
+          </p:cNvSpPr>
+          <p:nvPr>
+            <p:ph type="sldImg"/>
+          </p:nvPr>
+        </p:nvSpPr>
+        <p:spPr/>
+      </p:sp>
+      <p:sp>
+        <p:nvSpPr>
+          <p:cNvPr id="3" name="Notes Placeholder 2"/>
+          <p:cNvSpPr>
+            <a:spLocks noGrp="1"/>
+          </p:cNvSpPr>
+          <p:nvPr>
+            <p:ph type="body" idx="1"/>
+          </p:nvPr>
+        </p:nvSpPr>
+        <p:spPr/>
+        <p:txBody>
+          <a:bodyPr/>
+          <a:lstStyle/>
+          <a:p>
+            <a:r>
+              <a:rPr lang="en-US" dirty="0"/>
+              <a:t/>
+            </a:r>
+            <a:endParaRPr lang="en-US" dirty="0"/>
+          </a:p>
+        </p:txBody>
+      </p:sp>
+      <p:sp>
+        <p:nvSpPr>
+          <p:cNvPr id="4" name="Slide Number Placeholder 3"/>
+          <p:cNvSpPr>
+            <a:spLocks noGrp="1"/>
+          </p:cNvSpPr>
+          <p:nvPr>
+            <p:ph type="sldNum" sz="quarter" idx="10"/>
+          </p:nvPr>
+        </p:nvSpPr>
+        <p:spPr/>
+        <p:txBody>
+          <a:bodyPr/>
+          <a:lstStyle/>
+          <a:p>
+            <a:fld id="{F7021451-1387-4CA6-816F-3879F97B5CBC}" type="slidenum">
+              <a:rPr lang="en-US"/>
+              <a:t>8</a:t>
             </a:fld>
             <a:endParaRPr lang="en-US"/>
           </a:p>
@@ -5260,26 +5349,1488 @@
                   <a:srgbClr val="141A22"/>
                 </a:solidFill>
               </a:rPr>
-              <a:t>What comes next</a:t>
+              <a:t>Against the brief: Track 3, the governed front door</a:t>
             </a:r>
             <a:endParaRPr lang="en-US" sz="3200" dirty="0"/>
           </a:p>
         </p:txBody>
       </p:sp>
-      <p:sp>
-        <p:nvSpPr>
-          <p:cNvPr id="3" name="panel Expiring access"/>
+      <p:graphicFrame>
+        <p:nvGraphicFramePr>
+          <p:cNvPr id="8" name="brief table"/>
+          <p:cNvGraphicFramePr>
+            <a:graphicFrameLocks noGrp="1"/>
+          </p:cNvGraphicFramePr>
+          <p:nvPr>
+            <p:extLst>
+              <p:ext uri="{D42A27DB-BD31-4B8C-83A1-F6EECF244321}">
+                <p14:modId xmlns:p14="http://schemas.microsoft.com/office/powerpoint/2010/main" val="1579011935"/>
+              </p:ext>
+            </p:extLst>
+          </p:nvPr>
+        </p:nvGraphicFramePr>
+        <p:xfrm>
+          <a:off x="822960" y="1417320"/>
+          <a:ext cx="10515600" cy="914400"/>
+        </p:xfrm>
+        <a:graphic>
+          <a:graphicData uri="http://schemas.openxmlformats.org/drawingml/2006/table">
+            <a:tbl>
+              <a:tblPr/>
+              <a:tblGrid>
+                <a:gridCol w="3840480"/>
+                <a:gridCol w="5577840"/>
+                <a:gridCol w="1097280"/>
+              </a:tblGrid>
+              <a:tr h="475488">
+                <a:tc>
+                  <a:txBody>
+                    <a:bodyPr/>
+                    <a:lstStyle/>
+                    <a:p>
+                      <a:pPr indent="0" marL="0">
+                        <a:buNone/>
+                      </a:pPr>
+                      <a:r>
+                        <a:rPr lang="en-US" sz="1200" b="1" dirty="0">
+                          <a:solidFill>
+                            <a:srgbClr val="6B7280"/>
+                          </a:solidFill>
+                          <a:latin typeface="+mn-lt" pitchFamily="34" charset="0"/>
+                          <a:ea typeface="+mn-lt" pitchFamily="34" charset="-122"/>
+                          <a:cs typeface="+mn-lt" pitchFamily="34" charset="-120"/>
+                        </a:rPr>
+                        <a:t>Colibri asked for</a:t>
+                      </a:r>
+                      <a:endParaRPr lang="en-US" sz="1200" dirty="0">
+                        <a:latin typeface="+mn-lt" charset="0"/>
+                        <a:ea typeface="+mn-lt" charset="0"/>
+                        <a:cs typeface="+mn-lt" charset="0"/>
+                      </a:endParaRPr>
+                    </a:p>
+                  </a:txBody>
+                  <a:tcPr marL="73152" marR="73152" marT="73152" marB="73152">
+                    <a:lnL w="6350" cap="flat" cmpd="sng" algn="ctr">
+                      <a:solidFill>
+                        <a:srgbClr val="DDE2EA"/>
+                      </a:solidFill>
+                      <a:prstDash val="solid"/>
+                      <a:round/>
+                      <a:headEnd type="none" w="med" len="med"/>
+                      <a:tailEnd type="none" w="med" len="med"/>
+                    </a:lnL>
+                    <a:lnR w="6350" cap="flat" cmpd="sng" algn="ctr">
+                      <a:solidFill>
+                        <a:srgbClr val="DDE2EA"/>
+                      </a:solidFill>
+                      <a:prstDash val="solid"/>
+                      <a:round/>
+                      <a:headEnd type="none" w="med" len="med"/>
+                      <a:tailEnd type="none" w="med" len="med"/>
+                    </a:lnR>
+                    <a:lnT w="6350" cap="flat" cmpd="sng" algn="ctr">
+                      <a:solidFill>
+                        <a:srgbClr val="DDE2EA"/>
+                      </a:solidFill>
+                      <a:prstDash val="solid"/>
+                      <a:round/>
+                      <a:headEnd type="none" w="med" len="med"/>
+                      <a:tailEnd type="none" w="med" len="med"/>
+                    </a:lnT>
+                    <a:lnB w="6350" cap="flat" cmpd="sng" algn="ctr">
+                      <a:solidFill>
+                        <a:srgbClr val="DDE2EA"/>
+                      </a:solidFill>
+                      <a:prstDash val="solid"/>
+                      <a:round/>
+                      <a:headEnd type="none" w="med" len="med"/>
+                      <a:tailEnd type="none" w="med" len="med"/>
+                    </a:lnB>
+                    <a:solidFill>
+                      <a:srgbClr val="FFFFFF"/>
+                    </a:solidFill>
+                  </a:tcPr>
+                </a:tc>
+                <a:tc>
+                  <a:txBody>
+                    <a:bodyPr/>
+                    <a:lstStyle/>
+                    <a:p>
+                      <a:pPr indent="0" marL="0">
+                        <a:buNone/>
+                      </a:pPr>
+                      <a:r>
+                        <a:rPr lang="en-US" sz="1200" b="1" dirty="0">
+                          <a:solidFill>
+                            <a:srgbClr val="6B7280"/>
+                          </a:solidFill>
+                          <a:latin typeface="+mn-lt" pitchFamily="34" charset="0"/>
+                          <a:ea typeface="+mn-lt" pitchFamily="34" charset="-122"/>
+                          <a:cs typeface="+mn-lt" pitchFamily="34" charset="-120"/>
+                        </a:rPr>
+                        <a:t>Doorman</a:t>
+                      </a:r>
+                      <a:endParaRPr lang="en-US" sz="1200" dirty="0">
+                        <a:latin typeface="+mn-lt" charset="0"/>
+                        <a:ea typeface="+mn-lt" charset="0"/>
+                        <a:cs typeface="+mn-lt" charset="0"/>
+                      </a:endParaRPr>
+                    </a:p>
+                  </a:txBody>
+                  <a:tcPr marL="73152" marR="73152" marT="73152" marB="73152">
+                    <a:lnL w="6350" cap="flat" cmpd="sng" algn="ctr">
+                      <a:solidFill>
+                        <a:srgbClr val="DDE2EA"/>
+                      </a:solidFill>
+                      <a:prstDash val="solid"/>
+                      <a:round/>
+                      <a:headEnd type="none" w="med" len="med"/>
+                      <a:tailEnd type="none" w="med" len="med"/>
+                    </a:lnL>
+                    <a:lnR w="6350" cap="flat" cmpd="sng" algn="ctr">
+                      <a:solidFill>
+                        <a:srgbClr val="DDE2EA"/>
+                      </a:solidFill>
+                      <a:prstDash val="solid"/>
+                      <a:round/>
+                      <a:headEnd type="none" w="med" len="med"/>
+                      <a:tailEnd type="none" w="med" len="med"/>
+                    </a:lnR>
+                    <a:lnT w="6350" cap="flat" cmpd="sng" algn="ctr">
+                      <a:solidFill>
+                        <a:srgbClr val="DDE2EA"/>
+                      </a:solidFill>
+                      <a:prstDash val="solid"/>
+                      <a:round/>
+                      <a:headEnd type="none" w="med" len="med"/>
+                      <a:tailEnd type="none" w="med" len="med"/>
+                    </a:lnT>
+                    <a:lnB w="6350" cap="flat" cmpd="sng" algn="ctr">
+                      <a:solidFill>
+                        <a:srgbClr val="DDE2EA"/>
+                      </a:solidFill>
+                      <a:prstDash val="solid"/>
+                      <a:round/>
+                      <a:headEnd type="none" w="med" len="med"/>
+                      <a:tailEnd type="none" w="med" len="med"/>
+                    </a:lnB>
+                    <a:solidFill>
+                      <a:srgbClr val="FFFFFF"/>
+                    </a:solidFill>
+                  </a:tcPr>
+                </a:tc>
+                <a:tc>
+                  <a:txBody>
+                    <a:bodyPr/>
+                    <a:lstStyle/>
+                    <a:p>
+                      <a:pPr indent="0" marL="0">
+                        <a:buNone/>
+                      </a:pPr>
+                      <a:endParaRPr lang="en-US" sz="1200" dirty="0">
+                        <a:latin typeface="+mn-lt" charset="0"/>
+                        <a:ea typeface="+mn-lt" charset="0"/>
+                        <a:cs typeface="+mn-lt" charset="0"/>
+                      </a:endParaRPr>
+                    </a:p>
+                  </a:txBody>
+                  <a:tcPr marL="73152" marR="73152" marT="73152" marB="73152">
+                    <a:lnL w="6350" cap="flat" cmpd="sng" algn="ctr">
+                      <a:solidFill>
+                        <a:srgbClr val="DDE2EA"/>
+                      </a:solidFill>
+                      <a:prstDash val="solid"/>
+                      <a:round/>
+                      <a:headEnd type="none" w="med" len="med"/>
+                      <a:tailEnd type="none" w="med" len="med"/>
+                    </a:lnL>
+                    <a:lnR w="6350" cap="flat" cmpd="sng" algn="ctr">
+                      <a:solidFill>
+                        <a:srgbClr val="DDE2EA"/>
+                      </a:solidFill>
+                      <a:prstDash val="solid"/>
+                      <a:round/>
+                      <a:headEnd type="none" w="med" len="med"/>
+                      <a:tailEnd type="none" w="med" len="med"/>
+                    </a:lnR>
+                    <a:lnT w="6350" cap="flat" cmpd="sng" algn="ctr">
+                      <a:solidFill>
+                        <a:srgbClr val="DDE2EA"/>
+                      </a:solidFill>
+                      <a:prstDash val="solid"/>
+                      <a:round/>
+                      <a:headEnd type="none" w="med" len="med"/>
+                      <a:tailEnd type="none" w="med" len="med"/>
+                    </a:lnT>
+                    <a:lnB w="6350" cap="flat" cmpd="sng" algn="ctr">
+                      <a:solidFill>
+                        <a:srgbClr val="DDE2EA"/>
+                      </a:solidFill>
+                      <a:prstDash val="solid"/>
+                      <a:round/>
+                      <a:headEnd type="none" w="med" len="med"/>
+                      <a:tailEnd type="none" w="med" len="med"/>
+                    </a:lnB>
+                    <a:solidFill>
+                      <a:srgbClr val="FFFFFF"/>
+                    </a:solidFill>
+                  </a:tcPr>
+                </a:tc>
+              </a:tr>
+              <a:tr h="475488">
+                <a:tc>
+                  <a:txBody>
+                    <a:bodyPr/>
+                    <a:lstStyle/>
+                    <a:p>
+                      <a:pPr indent="0" marL="0">
+                        <a:buNone/>
+                      </a:pPr>
+                      <a:r>
+                        <a:rPr lang="en-US" sz="1250" dirty="0">
+                          <a:solidFill>
+                            <a:srgbClr val="141A22"/>
+                          </a:solidFill>
+                          <a:latin typeface="+mn-lt" pitchFamily="34" charset="0"/>
+                          <a:ea typeface="+mn-lt" pitchFamily="34" charset="-122"/>
+                          <a:cs typeface="+mn-lt" pitchFamily="34" charset="-120"/>
+                        </a:rPr>
+                        <a:t>Request in the app: pick a Unity Catalog asset, give a reason</a:t>
+                      </a:r>
+                      <a:endParaRPr lang="en-US" sz="1250" dirty="0">
+                        <a:latin typeface="+mn-lt" charset="0"/>
+                        <a:ea typeface="+mn-lt" charset="0"/>
+                        <a:cs typeface="+mn-lt" charset="0"/>
+                      </a:endParaRPr>
+                    </a:p>
+                  </a:txBody>
+                  <a:tcPr marL="73152" marR="73152" marT="73152" marB="73152" anchor="ctr">
+                    <a:lnL w="6350" cap="flat" cmpd="sng" algn="ctr">
+                      <a:solidFill>
+                        <a:srgbClr val="DDE2EA"/>
+                      </a:solidFill>
+                      <a:prstDash val="solid"/>
+                      <a:round/>
+                      <a:headEnd type="none" w="med" len="med"/>
+                      <a:tailEnd type="none" w="med" len="med"/>
+                    </a:lnL>
+                    <a:lnR w="6350" cap="flat" cmpd="sng" algn="ctr">
+                      <a:solidFill>
+                        <a:srgbClr val="DDE2EA"/>
+                      </a:solidFill>
+                      <a:prstDash val="solid"/>
+                      <a:round/>
+                      <a:headEnd type="none" w="med" len="med"/>
+                      <a:tailEnd type="none" w="med" len="med"/>
+                    </a:lnR>
+                    <a:lnT w="6350" cap="flat" cmpd="sng" algn="ctr">
+                      <a:solidFill>
+                        <a:srgbClr val="DDE2EA"/>
+                      </a:solidFill>
+                      <a:prstDash val="solid"/>
+                      <a:round/>
+                      <a:headEnd type="none" w="med" len="med"/>
+                      <a:tailEnd type="none" w="med" len="med"/>
+                    </a:lnT>
+                    <a:lnB w="6350" cap="flat" cmpd="sng" algn="ctr">
+                      <a:solidFill>
+                        <a:srgbClr val="DDE2EA"/>
+                      </a:solidFill>
+                      <a:prstDash val="solid"/>
+                      <a:round/>
+                      <a:headEnd type="none" w="med" len="med"/>
+                      <a:tailEnd type="none" w="med" len="med"/>
+                    </a:lnB>
+                    <a:solidFill>
+                      <a:srgbClr val="FFFFFF"/>
+                    </a:solidFill>
+                  </a:tcPr>
+                </a:tc>
+                <a:tc>
+                  <a:txBody>
+                    <a:bodyPr/>
+                    <a:lstStyle/>
+                    <a:p>
+                      <a:pPr indent="0" marL="0">
+                        <a:buNone/>
+                      </a:pPr>
+                      <a:r>
+                        <a:rPr lang="en-US" sz="1250" dirty="0">
+                          <a:solidFill>
+                            <a:srgbClr val="141A22"/>
+                          </a:solidFill>
+                          <a:latin typeface="+mn-lt" pitchFamily="34" charset="0"/>
+                          <a:ea typeface="+mn-lt" pitchFamily="34" charset="-122"/>
+                          <a:cs typeface="+mn-lt" pitchFamily="34" charset="-120"/>
+                        </a:rPr>
+                        <a:t>Catalogue page lists every tagged table; a reason is required and AI-flagged if vague</a:t>
+                      </a:r>
+                      <a:endParaRPr lang="en-US" sz="1250" dirty="0">
+                        <a:latin typeface="+mn-lt" charset="0"/>
+                        <a:ea typeface="+mn-lt" charset="0"/>
+                        <a:cs typeface="+mn-lt" charset="0"/>
+                      </a:endParaRPr>
+                    </a:p>
+                  </a:txBody>
+                  <a:tcPr marL="73152" marR="73152" marT="73152" marB="73152" anchor="ctr">
+                    <a:lnL w="6350" cap="flat" cmpd="sng" algn="ctr">
+                      <a:solidFill>
+                        <a:srgbClr val="DDE2EA"/>
+                      </a:solidFill>
+                      <a:prstDash val="solid"/>
+                      <a:round/>
+                      <a:headEnd type="none" w="med" len="med"/>
+                      <a:tailEnd type="none" w="med" len="med"/>
+                    </a:lnL>
+                    <a:lnR w="6350" cap="flat" cmpd="sng" algn="ctr">
+                      <a:solidFill>
+                        <a:srgbClr val="DDE2EA"/>
+                      </a:solidFill>
+                      <a:prstDash val="solid"/>
+                      <a:round/>
+                      <a:headEnd type="none" w="med" len="med"/>
+                      <a:tailEnd type="none" w="med" len="med"/>
+                    </a:lnR>
+                    <a:lnT w="6350" cap="flat" cmpd="sng" algn="ctr">
+                      <a:solidFill>
+                        <a:srgbClr val="DDE2EA"/>
+                      </a:solidFill>
+                      <a:prstDash val="solid"/>
+                      <a:round/>
+                      <a:headEnd type="none" w="med" len="med"/>
+                      <a:tailEnd type="none" w="med" len="med"/>
+                    </a:lnT>
+                    <a:lnB w="6350" cap="flat" cmpd="sng" algn="ctr">
+                      <a:solidFill>
+                        <a:srgbClr val="DDE2EA"/>
+                      </a:solidFill>
+                      <a:prstDash val="solid"/>
+                      <a:round/>
+                      <a:headEnd type="none" w="med" len="med"/>
+                      <a:tailEnd type="none" w="med" len="med"/>
+                    </a:lnB>
+                    <a:solidFill>
+                      <a:srgbClr val="FFFFFF"/>
+                    </a:solidFill>
+                  </a:tcPr>
+                </a:tc>
+                <a:tc>
+                  <a:txBody>
+                    <a:bodyPr/>
+                    <a:lstStyle/>
+                    <a:p>
+                      <a:pPr indent="0" marL="0">
+                        <a:buNone/>
+                      </a:pPr>
+                      <a:r>
+                        <a:rPr lang="en-US" sz="1250" b="1" dirty="0">
+                          <a:solidFill>
+                            <a:srgbClr val="1B8A4C"/>
+                          </a:solidFill>
+                          <a:latin typeface="+mn-lt" pitchFamily="34" charset="0"/>
+                          <a:ea typeface="+mn-lt" pitchFamily="34" charset="-122"/>
+                          <a:cs typeface="+mn-lt" pitchFamily="34" charset="-120"/>
+                        </a:rPr>
+                        <a:t>Done</a:t>
+                      </a:r>
+                      <a:endParaRPr lang="en-US" sz="1250" dirty="0">
+                        <a:latin typeface="+mn-lt" charset="0"/>
+                        <a:ea typeface="+mn-lt" charset="0"/>
+                        <a:cs typeface="+mn-lt" charset="0"/>
+                      </a:endParaRPr>
+                    </a:p>
+                  </a:txBody>
+                  <a:tcPr marL="73152" marR="73152" marT="73152" marB="73152" anchor="ctr">
+                    <a:lnL w="6350" cap="flat" cmpd="sng" algn="ctr">
+                      <a:solidFill>
+                        <a:srgbClr val="DDE2EA"/>
+                      </a:solidFill>
+                      <a:prstDash val="solid"/>
+                      <a:round/>
+                      <a:headEnd type="none" w="med" len="med"/>
+                      <a:tailEnd type="none" w="med" len="med"/>
+                    </a:lnL>
+                    <a:lnR w="6350" cap="flat" cmpd="sng" algn="ctr">
+                      <a:solidFill>
+                        <a:srgbClr val="DDE2EA"/>
+                      </a:solidFill>
+                      <a:prstDash val="solid"/>
+                      <a:round/>
+                      <a:headEnd type="none" w="med" len="med"/>
+                      <a:tailEnd type="none" w="med" len="med"/>
+                    </a:lnR>
+                    <a:lnT w="6350" cap="flat" cmpd="sng" algn="ctr">
+                      <a:solidFill>
+                        <a:srgbClr val="DDE2EA"/>
+                      </a:solidFill>
+                      <a:prstDash val="solid"/>
+                      <a:round/>
+                      <a:headEnd type="none" w="med" len="med"/>
+                      <a:tailEnd type="none" w="med" len="med"/>
+                    </a:lnT>
+                    <a:lnB w="6350" cap="flat" cmpd="sng" algn="ctr">
+                      <a:solidFill>
+                        <a:srgbClr val="DDE2EA"/>
+                      </a:solidFill>
+                      <a:prstDash val="solid"/>
+                      <a:round/>
+                      <a:headEnd type="none" w="med" len="med"/>
+                      <a:tailEnd type="none" w="med" len="med"/>
+                    </a:lnB>
+                    <a:solidFill>
+                      <a:srgbClr val="FFFFFF"/>
+                    </a:solidFill>
+                  </a:tcPr>
+                </a:tc>
+              </a:tr>
+              <a:tr h="475488">
+                <a:tc>
+                  <a:txBody>
+                    <a:bodyPr/>
+                    <a:lstStyle/>
+                    <a:p>
+                      <a:pPr indent="0" marL="0">
+                        <a:buNone/>
+                      </a:pPr>
+                      <a:r>
+                        <a:rPr lang="en-US" sz="1250" dirty="0">
+                          <a:solidFill>
+                            <a:srgbClr val="141A22"/>
+                          </a:solidFill>
+                          <a:latin typeface="+mn-lt" pitchFamily="34" charset="0"/>
+                          <a:ea typeface="+mn-lt" pitchFamily="34" charset="-122"/>
+                          <a:cs typeface="+mn-lt" pitchFamily="34" charset="-120"/>
+                        </a:rPr>
+                        <a:t>Route to the right approver from UC ownership or tags</a:t>
+                      </a:r>
+                      <a:endParaRPr lang="en-US" sz="1250" dirty="0">
+                        <a:latin typeface="+mn-lt" charset="0"/>
+                        <a:ea typeface="+mn-lt" charset="0"/>
+                        <a:cs typeface="+mn-lt" charset="0"/>
+                      </a:endParaRPr>
+                    </a:p>
+                  </a:txBody>
+                  <a:tcPr marL="73152" marR="73152" marT="73152" marB="73152" anchor="ctr">
+                    <a:lnL w="6350" cap="flat" cmpd="sng" algn="ctr">
+                      <a:solidFill>
+                        <a:srgbClr val="DDE2EA"/>
+                      </a:solidFill>
+                      <a:prstDash val="solid"/>
+                      <a:round/>
+                      <a:headEnd type="none" w="med" len="med"/>
+                      <a:tailEnd type="none" w="med" len="med"/>
+                    </a:lnL>
+                    <a:lnR w="6350" cap="flat" cmpd="sng" algn="ctr">
+                      <a:solidFill>
+                        <a:srgbClr val="DDE2EA"/>
+                      </a:solidFill>
+                      <a:prstDash val="solid"/>
+                      <a:round/>
+                      <a:headEnd type="none" w="med" len="med"/>
+                      <a:tailEnd type="none" w="med" len="med"/>
+                    </a:lnR>
+                    <a:lnT w="6350" cap="flat" cmpd="sng" algn="ctr">
+                      <a:solidFill>
+                        <a:srgbClr val="DDE2EA"/>
+                      </a:solidFill>
+                      <a:prstDash val="solid"/>
+                      <a:round/>
+                      <a:headEnd type="none" w="med" len="med"/>
+                      <a:tailEnd type="none" w="med" len="med"/>
+                    </a:lnT>
+                    <a:lnB w="6350" cap="flat" cmpd="sng" algn="ctr">
+                      <a:solidFill>
+                        <a:srgbClr val="DDE2EA"/>
+                      </a:solidFill>
+                      <a:prstDash val="solid"/>
+                      <a:round/>
+                      <a:headEnd type="none" w="med" len="med"/>
+                      <a:tailEnd type="none" w="med" len="med"/>
+                    </a:lnB>
+                    <a:solidFill>
+                      <a:srgbClr val="FFFFFF"/>
+                    </a:solidFill>
+                  </a:tcPr>
+                </a:tc>
+                <a:tc>
+                  <a:txBody>
+                    <a:bodyPr/>
+                    <a:lstStyle/>
+                    <a:p>
+                      <a:pPr indent="0" marL="0">
+                        <a:buNone/>
+                      </a:pPr>
+                      <a:r>
+                        <a:rPr lang="en-US" sz="1250" dirty="0">
+                          <a:solidFill>
+                            <a:srgbClr val="141A22"/>
+                          </a:solidFill>
+                          <a:latin typeface="+mn-lt" pitchFamily="34" charset="0"/>
+                          <a:ea typeface="+mn-lt" pitchFamily="34" charset="-122"/>
+                          <a:cs typeface="+mn-lt" pitchFamily="34" charset="-120"/>
+                        </a:rPr>
+                        <a:t>Approver read from the data_owner tag at request time; two owners live tonight</a:t>
+                      </a:r>
+                      <a:endParaRPr lang="en-US" sz="1250" dirty="0">
+                        <a:latin typeface="+mn-lt" charset="0"/>
+                        <a:ea typeface="+mn-lt" charset="0"/>
+                        <a:cs typeface="+mn-lt" charset="0"/>
+                      </a:endParaRPr>
+                    </a:p>
+                  </a:txBody>
+                  <a:tcPr marL="73152" marR="73152" marT="73152" marB="73152" anchor="ctr">
+                    <a:lnL w="6350" cap="flat" cmpd="sng" algn="ctr">
+                      <a:solidFill>
+                        <a:srgbClr val="DDE2EA"/>
+                      </a:solidFill>
+                      <a:prstDash val="solid"/>
+                      <a:round/>
+                      <a:headEnd type="none" w="med" len="med"/>
+                      <a:tailEnd type="none" w="med" len="med"/>
+                    </a:lnL>
+                    <a:lnR w="6350" cap="flat" cmpd="sng" algn="ctr">
+                      <a:solidFill>
+                        <a:srgbClr val="DDE2EA"/>
+                      </a:solidFill>
+                      <a:prstDash val="solid"/>
+                      <a:round/>
+                      <a:headEnd type="none" w="med" len="med"/>
+                      <a:tailEnd type="none" w="med" len="med"/>
+                    </a:lnR>
+                    <a:lnT w="6350" cap="flat" cmpd="sng" algn="ctr">
+                      <a:solidFill>
+                        <a:srgbClr val="DDE2EA"/>
+                      </a:solidFill>
+                      <a:prstDash val="solid"/>
+                      <a:round/>
+                      <a:headEnd type="none" w="med" len="med"/>
+                      <a:tailEnd type="none" w="med" len="med"/>
+                    </a:lnT>
+                    <a:lnB w="6350" cap="flat" cmpd="sng" algn="ctr">
+                      <a:solidFill>
+                        <a:srgbClr val="DDE2EA"/>
+                      </a:solidFill>
+                      <a:prstDash val="solid"/>
+                      <a:round/>
+                      <a:headEnd type="none" w="med" len="med"/>
+                      <a:tailEnd type="none" w="med" len="med"/>
+                    </a:lnB>
+                    <a:solidFill>
+                      <a:srgbClr val="FFFFFF"/>
+                    </a:solidFill>
+                  </a:tcPr>
+                </a:tc>
+                <a:tc>
+                  <a:txBody>
+                    <a:bodyPr/>
+                    <a:lstStyle/>
+                    <a:p>
+                      <a:pPr indent="0" marL="0">
+                        <a:buNone/>
+                      </a:pPr>
+                      <a:r>
+                        <a:rPr lang="en-US" sz="1250" b="1" dirty="0">
+                          <a:solidFill>
+                            <a:srgbClr val="1B8A4C"/>
+                          </a:solidFill>
+                          <a:latin typeface="+mn-lt" pitchFamily="34" charset="0"/>
+                          <a:ea typeface="+mn-lt" pitchFamily="34" charset="-122"/>
+                          <a:cs typeface="+mn-lt" pitchFamily="34" charset="-120"/>
+                        </a:rPr>
+                        <a:t>Done</a:t>
+                      </a:r>
+                      <a:endParaRPr lang="en-US" sz="1250" dirty="0">
+                        <a:latin typeface="+mn-lt" charset="0"/>
+                        <a:ea typeface="+mn-lt" charset="0"/>
+                        <a:cs typeface="+mn-lt" charset="0"/>
+                      </a:endParaRPr>
+                    </a:p>
+                  </a:txBody>
+                  <a:tcPr marL="73152" marR="73152" marT="73152" marB="73152" anchor="ctr">
+                    <a:lnL w="6350" cap="flat" cmpd="sng" algn="ctr">
+                      <a:solidFill>
+                        <a:srgbClr val="DDE2EA"/>
+                      </a:solidFill>
+                      <a:prstDash val="solid"/>
+                      <a:round/>
+                      <a:headEnd type="none" w="med" len="med"/>
+                      <a:tailEnd type="none" w="med" len="med"/>
+                    </a:lnL>
+                    <a:lnR w="6350" cap="flat" cmpd="sng" algn="ctr">
+                      <a:solidFill>
+                        <a:srgbClr val="DDE2EA"/>
+                      </a:solidFill>
+                      <a:prstDash val="solid"/>
+                      <a:round/>
+                      <a:headEnd type="none" w="med" len="med"/>
+                      <a:tailEnd type="none" w="med" len="med"/>
+                    </a:lnR>
+                    <a:lnT w="6350" cap="flat" cmpd="sng" algn="ctr">
+                      <a:solidFill>
+                        <a:srgbClr val="DDE2EA"/>
+                      </a:solidFill>
+                      <a:prstDash val="solid"/>
+                      <a:round/>
+                      <a:headEnd type="none" w="med" len="med"/>
+                      <a:tailEnd type="none" w="med" len="med"/>
+                    </a:lnT>
+                    <a:lnB w="6350" cap="flat" cmpd="sng" algn="ctr">
+                      <a:solidFill>
+                        <a:srgbClr val="DDE2EA"/>
+                      </a:solidFill>
+                      <a:prstDash val="solid"/>
+                      <a:round/>
+                      <a:headEnd type="none" w="med" len="med"/>
+                      <a:tailEnd type="none" w="med" len="med"/>
+                    </a:lnB>
+                    <a:solidFill>
+                      <a:srgbClr val="FFFFFF"/>
+                    </a:solidFill>
+                  </a:tcPr>
+                </a:tc>
+              </a:tr>
+              <a:tr h="475488">
+                <a:tc>
+                  <a:txBody>
+                    <a:bodyPr/>
+                    <a:lstStyle/>
+                    <a:p>
+                      <a:pPr indent="0" marL="0">
+                        <a:buNone/>
+                      </a:pPr>
+                      <a:r>
+                        <a:rPr lang="en-US" sz="1250" dirty="0">
+                          <a:solidFill>
+                            <a:srgbClr val="141A22"/>
+                          </a:solidFill>
+                          <a:latin typeface="+mn-lt" pitchFamily="34" charset="0"/>
+                          <a:ea typeface="+mn-lt" pitchFamily="34" charset="-122"/>
+                          <a:cs typeface="+mn-lt" pitchFamily="34" charset="-120"/>
+                        </a:rPr>
+                        <a:t>Approve applies a real UC grant and informs the requester; reject blocks and says why</a:t>
+                      </a:r>
+                      <a:endParaRPr lang="en-US" sz="1250" dirty="0">
+                        <a:latin typeface="+mn-lt" charset="0"/>
+                        <a:ea typeface="+mn-lt" charset="0"/>
+                        <a:cs typeface="+mn-lt" charset="0"/>
+                      </a:endParaRPr>
+                    </a:p>
+                  </a:txBody>
+                  <a:tcPr marL="73152" marR="73152" marT="73152" marB="73152" anchor="ctr">
+                    <a:lnL w="6350" cap="flat" cmpd="sng" algn="ctr">
+                      <a:solidFill>
+                        <a:srgbClr val="DDE2EA"/>
+                      </a:solidFill>
+                      <a:prstDash val="solid"/>
+                      <a:round/>
+                      <a:headEnd type="none" w="med" len="med"/>
+                      <a:tailEnd type="none" w="med" len="med"/>
+                    </a:lnL>
+                    <a:lnR w="6350" cap="flat" cmpd="sng" algn="ctr">
+                      <a:solidFill>
+                        <a:srgbClr val="DDE2EA"/>
+                      </a:solidFill>
+                      <a:prstDash val="solid"/>
+                      <a:round/>
+                      <a:headEnd type="none" w="med" len="med"/>
+                      <a:tailEnd type="none" w="med" len="med"/>
+                    </a:lnR>
+                    <a:lnT w="6350" cap="flat" cmpd="sng" algn="ctr">
+                      <a:solidFill>
+                        <a:srgbClr val="DDE2EA"/>
+                      </a:solidFill>
+                      <a:prstDash val="solid"/>
+                      <a:round/>
+                      <a:headEnd type="none" w="med" len="med"/>
+                      <a:tailEnd type="none" w="med" len="med"/>
+                    </a:lnT>
+                    <a:lnB w="6350" cap="flat" cmpd="sng" algn="ctr">
+                      <a:solidFill>
+                        <a:srgbClr val="DDE2EA"/>
+                      </a:solidFill>
+                      <a:prstDash val="solid"/>
+                      <a:round/>
+                      <a:headEnd type="none" w="med" len="med"/>
+                      <a:tailEnd type="none" w="med" len="med"/>
+                    </a:lnB>
+                    <a:solidFill>
+                      <a:srgbClr val="FFFFFF"/>
+                    </a:solidFill>
+                  </a:tcPr>
+                </a:tc>
+                <a:tc>
+                  <a:txBody>
+                    <a:bodyPr/>
+                    <a:lstStyle/>
+                    <a:p>
+                      <a:pPr indent="0" marL="0">
+                        <a:buNone/>
+                      </a:pPr>
+                      <a:r>
+                        <a:rPr lang="en-US" sz="1250" dirty="0">
+                          <a:solidFill>
+                            <a:srgbClr val="141A22"/>
+                          </a:solidFill>
+                          <a:latin typeface="+mn-lt" pitchFamily="34" charset="0"/>
+                          <a:ea typeface="+mn-lt" pitchFamily="34" charset="-122"/>
+                          <a:cs typeface="+mn-lt" pitchFamily="34" charset="-120"/>
+                        </a:rPr>
+                        <a:t>GRANT SELECT in Unity Catalog; status and the owner's note shown in-app; revoke keeps the record</a:t>
+                      </a:r>
+                      <a:endParaRPr lang="en-US" sz="1250" dirty="0">
+                        <a:latin typeface="+mn-lt" charset="0"/>
+                        <a:ea typeface="+mn-lt" charset="0"/>
+                        <a:cs typeface="+mn-lt" charset="0"/>
+                      </a:endParaRPr>
+                    </a:p>
+                  </a:txBody>
+                  <a:tcPr marL="73152" marR="73152" marT="73152" marB="73152" anchor="ctr">
+                    <a:lnL w="6350" cap="flat" cmpd="sng" algn="ctr">
+                      <a:solidFill>
+                        <a:srgbClr val="DDE2EA"/>
+                      </a:solidFill>
+                      <a:prstDash val="solid"/>
+                      <a:round/>
+                      <a:headEnd type="none" w="med" len="med"/>
+                      <a:tailEnd type="none" w="med" len="med"/>
+                    </a:lnL>
+                    <a:lnR w="6350" cap="flat" cmpd="sng" algn="ctr">
+                      <a:solidFill>
+                        <a:srgbClr val="DDE2EA"/>
+                      </a:solidFill>
+                      <a:prstDash val="solid"/>
+                      <a:round/>
+                      <a:headEnd type="none" w="med" len="med"/>
+                      <a:tailEnd type="none" w="med" len="med"/>
+                    </a:lnR>
+                    <a:lnT w="6350" cap="flat" cmpd="sng" algn="ctr">
+                      <a:solidFill>
+                        <a:srgbClr val="DDE2EA"/>
+                      </a:solidFill>
+                      <a:prstDash val="solid"/>
+                      <a:round/>
+                      <a:headEnd type="none" w="med" len="med"/>
+                      <a:tailEnd type="none" w="med" len="med"/>
+                    </a:lnT>
+                    <a:lnB w="6350" cap="flat" cmpd="sng" algn="ctr">
+                      <a:solidFill>
+                        <a:srgbClr val="DDE2EA"/>
+                      </a:solidFill>
+                      <a:prstDash val="solid"/>
+                      <a:round/>
+                      <a:headEnd type="none" w="med" len="med"/>
+                      <a:tailEnd type="none" w="med" len="med"/>
+                    </a:lnB>
+                    <a:solidFill>
+                      <a:srgbClr val="FFFFFF"/>
+                    </a:solidFill>
+                  </a:tcPr>
+                </a:tc>
+                <a:tc>
+                  <a:txBody>
+                    <a:bodyPr/>
+                    <a:lstStyle/>
+                    <a:p>
+                      <a:pPr indent="0" marL="0">
+                        <a:buNone/>
+                      </a:pPr>
+                      <a:r>
+                        <a:rPr lang="en-US" sz="1250" b="1" dirty="0">
+                          <a:solidFill>
+                            <a:srgbClr val="1B8A4C"/>
+                          </a:solidFill>
+                          <a:latin typeface="+mn-lt" pitchFamily="34" charset="0"/>
+                          <a:ea typeface="+mn-lt" pitchFamily="34" charset="-122"/>
+                          <a:cs typeface="+mn-lt" pitchFamily="34" charset="-120"/>
+                        </a:rPr>
+                        <a:t>Done</a:t>
+                      </a:r>
+                      <a:endParaRPr lang="en-US" sz="1250" dirty="0">
+                        <a:latin typeface="+mn-lt" charset="0"/>
+                        <a:ea typeface="+mn-lt" charset="0"/>
+                        <a:cs typeface="+mn-lt" charset="0"/>
+                      </a:endParaRPr>
+                    </a:p>
+                  </a:txBody>
+                  <a:tcPr marL="73152" marR="73152" marT="73152" marB="73152" anchor="ctr">
+                    <a:lnL w="6350" cap="flat" cmpd="sng" algn="ctr">
+                      <a:solidFill>
+                        <a:srgbClr val="DDE2EA"/>
+                      </a:solidFill>
+                      <a:prstDash val="solid"/>
+                      <a:round/>
+                      <a:headEnd type="none" w="med" len="med"/>
+                      <a:tailEnd type="none" w="med" len="med"/>
+                    </a:lnL>
+                    <a:lnR w="6350" cap="flat" cmpd="sng" algn="ctr">
+                      <a:solidFill>
+                        <a:srgbClr val="DDE2EA"/>
+                      </a:solidFill>
+                      <a:prstDash val="solid"/>
+                      <a:round/>
+                      <a:headEnd type="none" w="med" len="med"/>
+                      <a:tailEnd type="none" w="med" len="med"/>
+                    </a:lnR>
+                    <a:lnT w="6350" cap="flat" cmpd="sng" algn="ctr">
+                      <a:solidFill>
+                        <a:srgbClr val="DDE2EA"/>
+                      </a:solidFill>
+                      <a:prstDash val="solid"/>
+                      <a:round/>
+                      <a:headEnd type="none" w="med" len="med"/>
+                      <a:tailEnd type="none" w="med" len="med"/>
+                    </a:lnT>
+                    <a:lnB w="6350" cap="flat" cmpd="sng" algn="ctr">
+                      <a:solidFill>
+                        <a:srgbClr val="DDE2EA"/>
+                      </a:solidFill>
+                      <a:prstDash val="solid"/>
+                      <a:round/>
+                      <a:headEnd type="none" w="med" len="med"/>
+                      <a:tailEnd type="none" w="med" len="med"/>
+                    </a:lnB>
+                    <a:solidFill>
+                      <a:srgbClr val="FFFFFF"/>
+                    </a:solidFill>
+                  </a:tcPr>
+                </a:tc>
+              </a:tr>
+              <a:tr h="475488">
+                <a:tc>
+                  <a:txBody>
+                    <a:bodyPr/>
+                    <a:lstStyle/>
+                    <a:p>
+                      <a:pPr indent="0" marL="0">
+                        <a:buNone/>
+                      </a:pPr>
+                      <a:r>
+                        <a:rPr lang="en-US" sz="1250" dirty="0">
+                          <a:solidFill>
+                            <a:srgbClr val="141A22"/>
+                          </a:solidFill>
+                          <a:latin typeface="+mn-lt" pitchFamily="34" charset="0"/>
+                          <a:ea typeface="+mn-lt" pitchFamily="34" charset="-122"/>
+                          <a:cs typeface="+mn-lt" pitchFamily="34" charset="-120"/>
+                        </a:rPr>
+                        <a:t>Audit trail in a Delta table: who, what, when, outcome</a:t>
+                      </a:r>
+                      <a:endParaRPr lang="en-US" sz="1250" dirty="0">
+                        <a:latin typeface="+mn-lt" charset="0"/>
+                        <a:ea typeface="+mn-lt" charset="0"/>
+                        <a:cs typeface="+mn-lt" charset="0"/>
+                      </a:endParaRPr>
+                    </a:p>
+                  </a:txBody>
+                  <a:tcPr marL="73152" marR="73152" marT="73152" marB="73152" anchor="ctr">
+                    <a:lnL w="6350" cap="flat" cmpd="sng" algn="ctr">
+                      <a:solidFill>
+                        <a:srgbClr val="DDE2EA"/>
+                      </a:solidFill>
+                      <a:prstDash val="solid"/>
+                      <a:round/>
+                      <a:headEnd type="none" w="med" len="med"/>
+                      <a:tailEnd type="none" w="med" len="med"/>
+                    </a:lnL>
+                    <a:lnR w="6350" cap="flat" cmpd="sng" algn="ctr">
+                      <a:solidFill>
+                        <a:srgbClr val="DDE2EA"/>
+                      </a:solidFill>
+                      <a:prstDash val="solid"/>
+                      <a:round/>
+                      <a:headEnd type="none" w="med" len="med"/>
+                      <a:tailEnd type="none" w="med" len="med"/>
+                    </a:lnR>
+                    <a:lnT w="6350" cap="flat" cmpd="sng" algn="ctr">
+                      <a:solidFill>
+                        <a:srgbClr val="DDE2EA"/>
+                      </a:solidFill>
+                      <a:prstDash val="solid"/>
+                      <a:round/>
+                      <a:headEnd type="none" w="med" len="med"/>
+                      <a:tailEnd type="none" w="med" len="med"/>
+                    </a:lnT>
+                    <a:lnB w="6350" cap="flat" cmpd="sng" algn="ctr">
+                      <a:solidFill>
+                        <a:srgbClr val="DDE2EA"/>
+                      </a:solidFill>
+                      <a:prstDash val="solid"/>
+                      <a:round/>
+                      <a:headEnd type="none" w="med" len="med"/>
+                      <a:tailEnd type="none" w="med" len="med"/>
+                    </a:lnB>
+                    <a:solidFill>
+                      <a:srgbClr val="FFFFFF"/>
+                    </a:solidFill>
+                  </a:tcPr>
+                </a:tc>
+                <a:tc>
+                  <a:txBody>
+                    <a:bodyPr/>
+                    <a:lstStyle/>
+                    <a:p>
+                      <a:pPr indent="0" marL="0">
+                        <a:buNone/>
+                      </a:pPr>
+                      <a:r>
+                        <a:rPr lang="en-US" sz="1250" dirty="0">
+                          <a:solidFill>
+                            <a:srgbClr val="141A22"/>
+                          </a:solidFill>
+                          <a:latin typeface="+mn-lt" pitchFamily="34" charset="0"/>
+                          <a:ea typeface="+mn-lt" pitchFamily="34" charset="-122"/>
+                          <a:cs typeface="+mn-lt" pitchFamily="34" charset="-120"/>
+                        </a:rPr>
+                        <a:t>access_requests is the queue and the receipt; Genie answers questions on it</a:t>
+                      </a:r>
+                      <a:endParaRPr lang="en-US" sz="1250" dirty="0">
+                        <a:latin typeface="+mn-lt" charset="0"/>
+                        <a:ea typeface="+mn-lt" charset="0"/>
+                        <a:cs typeface="+mn-lt" charset="0"/>
+                      </a:endParaRPr>
+                    </a:p>
+                  </a:txBody>
+                  <a:tcPr marL="73152" marR="73152" marT="73152" marB="73152" anchor="ctr">
+                    <a:lnL w="6350" cap="flat" cmpd="sng" algn="ctr">
+                      <a:solidFill>
+                        <a:srgbClr val="DDE2EA"/>
+                      </a:solidFill>
+                      <a:prstDash val="solid"/>
+                      <a:round/>
+                      <a:headEnd type="none" w="med" len="med"/>
+                      <a:tailEnd type="none" w="med" len="med"/>
+                    </a:lnL>
+                    <a:lnR w="6350" cap="flat" cmpd="sng" algn="ctr">
+                      <a:solidFill>
+                        <a:srgbClr val="DDE2EA"/>
+                      </a:solidFill>
+                      <a:prstDash val="solid"/>
+                      <a:round/>
+                      <a:headEnd type="none" w="med" len="med"/>
+                      <a:tailEnd type="none" w="med" len="med"/>
+                    </a:lnR>
+                    <a:lnT w="6350" cap="flat" cmpd="sng" algn="ctr">
+                      <a:solidFill>
+                        <a:srgbClr val="DDE2EA"/>
+                      </a:solidFill>
+                      <a:prstDash val="solid"/>
+                      <a:round/>
+                      <a:headEnd type="none" w="med" len="med"/>
+                      <a:tailEnd type="none" w="med" len="med"/>
+                    </a:lnT>
+                    <a:lnB w="6350" cap="flat" cmpd="sng" algn="ctr">
+                      <a:solidFill>
+                        <a:srgbClr val="DDE2EA"/>
+                      </a:solidFill>
+                      <a:prstDash val="solid"/>
+                      <a:round/>
+                      <a:headEnd type="none" w="med" len="med"/>
+                      <a:tailEnd type="none" w="med" len="med"/>
+                    </a:lnB>
+                    <a:solidFill>
+                      <a:srgbClr val="FFFFFF"/>
+                    </a:solidFill>
+                  </a:tcPr>
+                </a:tc>
+                <a:tc>
+                  <a:txBody>
+                    <a:bodyPr/>
+                    <a:lstStyle/>
+                    <a:p>
+                      <a:pPr indent="0" marL="0">
+                        <a:buNone/>
+                      </a:pPr>
+                      <a:r>
+                        <a:rPr lang="en-US" sz="1250" b="1" dirty="0">
+                          <a:solidFill>
+                            <a:srgbClr val="1B8A4C"/>
+                          </a:solidFill>
+                          <a:latin typeface="+mn-lt" pitchFamily="34" charset="0"/>
+                          <a:ea typeface="+mn-lt" pitchFamily="34" charset="-122"/>
+                          <a:cs typeface="+mn-lt" pitchFamily="34" charset="-120"/>
+                        </a:rPr>
+                        <a:t>Done</a:t>
+                      </a:r>
+                      <a:endParaRPr lang="en-US" sz="1250" dirty="0">
+                        <a:latin typeface="+mn-lt" charset="0"/>
+                        <a:ea typeface="+mn-lt" charset="0"/>
+                        <a:cs typeface="+mn-lt" charset="0"/>
+                      </a:endParaRPr>
+                    </a:p>
+                  </a:txBody>
+                  <a:tcPr marL="73152" marR="73152" marT="73152" marB="73152" anchor="ctr">
+                    <a:lnL w="6350" cap="flat" cmpd="sng" algn="ctr">
+                      <a:solidFill>
+                        <a:srgbClr val="DDE2EA"/>
+                      </a:solidFill>
+                      <a:prstDash val="solid"/>
+                      <a:round/>
+                      <a:headEnd type="none" w="med" len="med"/>
+                      <a:tailEnd type="none" w="med" len="med"/>
+                    </a:lnL>
+                    <a:lnR w="6350" cap="flat" cmpd="sng" algn="ctr">
+                      <a:solidFill>
+                        <a:srgbClr val="DDE2EA"/>
+                      </a:solidFill>
+                      <a:prstDash val="solid"/>
+                      <a:round/>
+                      <a:headEnd type="none" w="med" len="med"/>
+                      <a:tailEnd type="none" w="med" len="med"/>
+                    </a:lnR>
+                    <a:lnT w="6350" cap="flat" cmpd="sng" algn="ctr">
+                      <a:solidFill>
+                        <a:srgbClr val="DDE2EA"/>
+                      </a:solidFill>
+                      <a:prstDash val="solid"/>
+                      <a:round/>
+                      <a:headEnd type="none" w="med" len="med"/>
+                      <a:tailEnd type="none" w="med" len="med"/>
+                    </a:lnT>
+                    <a:lnB w="6350" cap="flat" cmpd="sng" algn="ctr">
+                      <a:solidFill>
+                        <a:srgbClr val="DDE2EA"/>
+                      </a:solidFill>
+                      <a:prstDash val="solid"/>
+                      <a:round/>
+                      <a:headEnd type="none" w="med" len="med"/>
+                      <a:tailEnd type="none" w="med" len="med"/>
+                    </a:lnB>
+                    <a:solidFill>
+                      <a:srgbClr val="FFFFFF"/>
+                    </a:solidFill>
+                  </a:tcPr>
+                </a:tc>
+              </a:tr>
+              <a:tr h="475488">
+                <a:tc>
+                  <a:txBody>
+                    <a:bodyPr/>
+                    <a:lstStyle/>
+                    <a:p>
+                      <a:pPr indent="0" marL="0">
+                        <a:buNone/>
+                      </a:pPr>
+                      <a:r>
+                        <a:rPr lang="en-US" sz="1250" dirty="0">
+                          <a:solidFill>
+                            <a:srgbClr val="141A22"/>
+                          </a:solidFill>
+                          <a:latin typeface="+mn-lt" pitchFamily="34" charset="0"/>
+                          <a:ea typeface="+mn-lt" pitchFamily="34" charset="-122"/>
+                          <a:cs typeface="+mn-lt" pitchFamily="34" charset="-120"/>
+                        </a:rPr>
+                        <a:t>Scope: tables only, one approver per asset, in-app queue</a:t>
+                      </a:r>
+                      <a:endParaRPr lang="en-US" sz="1250" dirty="0">
+                        <a:latin typeface="+mn-lt" charset="0"/>
+                        <a:ea typeface="+mn-lt" charset="0"/>
+                        <a:cs typeface="+mn-lt" charset="0"/>
+                      </a:endParaRPr>
+                    </a:p>
+                  </a:txBody>
+                  <a:tcPr marL="73152" marR="73152" marT="73152" marB="73152" anchor="ctr">
+                    <a:lnL w="6350" cap="flat" cmpd="sng" algn="ctr">
+                      <a:solidFill>
+                        <a:srgbClr val="DDE2EA"/>
+                      </a:solidFill>
+                      <a:prstDash val="solid"/>
+                      <a:round/>
+                      <a:headEnd type="none" w="med" len="med"/>
+                      <a:tailEnd type="none" w="med" len="med"/>
+                    </a:lnL>
+                    <a:lnR w="6350" cap="flat" cmpd="sng" algn="ctr">
+                      <a:solidFill>
+                        <a:srgbClr val="DDE2EA"/>
+                      </a:solidFill>
+                      <a:prstDash val="solid"/>
+                      <a:round/>
+                      <a:headEnd type="none" w="med" len="med"/>
+                      <a:tailEnd type="none" w="med" len="med"/>
+                    </a:lnR>
+                    <a:lnT w="6350" cap="flat" cmpd="sng" algn="ctr">
+                      <a:solidFill>
+                        <a:srgbClr val="DDE2EA"/>
+                      </a:solidFill>
+                      <a:prstDash val="solid"/>
+                      <a:round/>
+                      <a:headEnd type="none" w="med" len="med"/>
+                      <a:tailEnd type="none" w="med" len="med"/>
+                    </a:lnT>
+                    <a:lnB w="6350" cap="flat" cmpd="sng" algn="ctr">
+                      <a:solidFill>
+                        <a:srgbClr val="DDE2EA"/>
+                      </a:solidFill>
+                      <a:prstDash val="solid"/>
+                      <a:round/>
+                      <a:headEnd type="none" w="med" len="med"/>
+                      <a:tailEnd type="none" w="med" len="med"/>
+                    </a:lnB>
+                    <a:solidFill>
+                      <a:srgbClr val="FFFFFF"/>
+                    </a:solidFill>
+                  </a:tcPr>
+                </a:tc>
+                <a:tc>
+                  <a:txBody>
+                    <a:bodyPr/>
+                    <a:lstStyle/>
+                    <a:p>
+                      <a:pPr indent="0" marL="0">
+                        <a:buNone/>
+                      </a:pPr>
+                      <a:r>
+                        <a:rPr lang="en-US" sz="1250" dirty="0">
+                          <a:solidFill>
+                            <a:srgbClr val="141A22"/>
+                          </a:solidFill>
+                          <a:latin typeface="+mn-lt" pitchFamily="34" charset="0"/>
+                          <a:ea typeface="+mn-lt" pitchFamily="34" charset="-122"/>
+                          <a:cs typeface="+mn-lt" pitchFamily="34" charset="-120"/>
+                        </a:rPr>
+                        <a:t>Exactly that, plus views as products</a:t>
+                      </a:r>
+                      <a:endParaRPr lang="en-US" sz="1250" dirty="0">
+                        <a:latin typeface="+mn-lt" charset="0"/>
+                        <a:ea typeface="+mn-lt" charset="0"/>
+                        <a:cs typeface="+mn-lt" charset="0"/>
+                      </a:endParaRPr>
+                    </a:p>
+                  </a:txBody>
+                  <a:tcPr marL="73152" marR="73152" marT="73152" marB="73152" anchor="ctr">
+                    <a:lnL w="6350" cap="flat" cmpd="sng" algn="ctr">
+                      <a:solidFill>
+                        <a:srgbClr val="DDE2EA"/>
+                      </a:solidFill>
+                      <a:prstDash val="solid"/>
+                      <a:round/>
+                      <a:headEnd type="none" w="med" len="med"/>
+                      <a:tailEnd type="none" w="med" len="med"/>
+                    </a:lnL>
+                    <a:lnR w="6350" cap="flat" cmpd="sng" algn="ctr">
+                      <a:solidFill>
+                        <a:srgbClr val="DDE2EA"/>
+                      </a:solidFill>
+                      <a:prstDash val="solid"/>
+                      <a:round/>
+                      <a:headEnd type="none" w="med" len="med"/>
+                      <a:tailEnd type="none" w="med" len="med"/>
+                    </a:lnR>
+                    <a:lnT w="6350" cap="flat" cmpd="sng" algn="ctr">
+                      <a:solidFill>
+                        <a:srgbClr val="DDE2EA"/>
+                      </a:solidFill>
+                      <a:prstDash val="solid"/>
+                      <a:round/>
+                      <a:headEnd type="none" w="med" len="med"/>
+                      <a:tailEnd type="none" w="med" len="med"/>
+                    </a:lnT>
+                    <a:lnB w="6350" cap="flat" cmpd="sng" algn="ctr">
+                      <a:solidFill>
+                        <a:srgbClr val="DDE2EA"/>
+                      </a:solidFill>
+                      <a:prstDash val="solid"/>
+                      <a:round/>
+                      <a:headEnd type="none" w="med" len="med"/>
+                      <a:tailEnd type="none" w="med" len="med"/>
+                    </a:lnB>
+                    <a:solidFill>
+                      <a:srgbClr val="FFFFFF"/>
+                    </a:solidFill>
+                  </a:tcPr>
+                </a:tc>
+                <a:tc>
+                  <a:txBody>
+                    <a:bodyPr/>
+                    <a:lstStyle/>
+                    <a:p>
+                      <a:pPr indent="0" marL="0">
+                        <a:buNone/>
+                      </a:pPr>
+                      <a:r>
+                        <a:rPr lang="en-US" sz="1250" b="1" dirty="0">
+                          <a:solidFill>
+                            <a:srgbClr val="1B8A4C"/>
+                          </a:solidFill>
+                          <a:latin typeface="+mn-lt" pitchFamily="34" charset="0"/>
+                          <a:ea typeface="+mn-lt" pitchFamily="34" charset="-122"/>
+                          <a:cs typeface="+mn-lt" pitchFamily="34" charset="-120"/>
+                        </a:rPr>
+                        <a:t>Done</a:t>
+                      </a:r>
+                      <a:endParaRPr lang="en-US" sz="1250" dirty="0">
+                        <a:latin typeface="+mn-lt" charset="0"/>
+                        <a:ea typeface="+mn-lt" charset="0"/>
+                        <a:cs typeface="+mn-lt" charset="0"/>
+                      </a:endParaRPr>
+                    </a:p>
+                  </a:txBody>
+                  <a:tcPr marL="73152" marR="73152" marT="73152" marB="73152" anchor="ctr">
+                    <a:lnL w="6350" cap="flat" cmpd="sng" algn="ctr">
+                      <a:solidFill>
+                        <a:srgbClr val="DDE2EA"/>
+                      </a:solidFill>
+                      <a:prstDash val="solid"/>
+                      <a:round/>
+                      <a:headEnd type="none" w="med" len="med"/>
+                      <a:tailEnd type="none" w="med" len="med"/>
+                    </a:lnL>
+                    <a:lnR w="6350" cap="flat" cmpd="sng" algn="ctr">
+                      <a:solidFill>
+                        <a:srgbClr val="DDE2EA"/>
+                      </a:solidFill>
+                      <a:prstDash val="solid"/>
+                      <a:round/>
+                      <a:headEnd type="none" w="med" len="med"/>
+                      <a:tailEnd type="none" w="med" len="med"/>
+                    </a:lnR>
+                    <a:lnT w="6350" cap="flat" cmpd="sng" algn="ctr">
+                      <a:solidFill>
+                        <a:srgbClr val="DDE2EA"/>
+                      </a:solidFill>
+                      <a:prstDash val="solid"/>
+                      <a:round/>
+                      <a:headEnd type="none" w="med" len="med"/>
+                      <a:tailEnd type="none" w="med" len="med"/>
+                    </a:lnT>
+                    <a:lnB w="6350" cap="flat" cmpd="sng" algn="ctr">
+                      <a:solidFill>
+                        <a:srgbClr val="DDE2EA"/>
+                      </a:solidFill>
+                      <a:prstDash val="solid"/>
+                      <a:round/>
+                      <a:headEnd type="none" w="med" len="med"/>
+                      <a:tailEnd type="none" w="med" len="med"/>
+                    </a:lnB>
+                    <a:solidFill>
+                      <a:srgbClr val="FFFFFF"/>
+                    </a:solidFill>
+                  </a:tcPr>
+                </a:tc>
+              </a:tr>
+              <a:tr h="475488">
+                <a:tc>
+                  <a:txBody>
+                    <a:bodyPr/>
+                    <a:lstStyle/>
+                    <a:p>
+                      <a:pPr indent="0" marL="0">
+                        <a:buNone/>
+                      </a:pPr>
+                      <a:r>
+                        <a:rPr lang="en-US" sz="1250" dirty="0">
+                          <a:solidFill>
+                            <a:srgbClr val="141A22"/>
+                          </a:solidFill>
+                          <a:latin typeface="+mn-lt" pitchFamily="34" charset="0"/>
+                          <a:ea typeface="+mn-lt" pitchFamily="34" charset="-122"/>
+                          <a:cs typeface="+mn-lt" pitchFamily="34" charset="-120"/>
+                        </a:rPr>
+                        <a:t>Stretch: Teams or email, time-boxed access</a:t>
+                      </a:r>
+                      <a:endParaRPr lang="en-US" sz="1250" dirty="0">
+                        <a:latin typeface="+mn-lt" charset="0"/>
+                        <a:ea typeface="+mn-lt" charset="0"/>
+                        <a:cs typeface="+mn-lt" charset="0"/>
+                      </a:endParaRPr>
+                    </a:p>
+                  </a:txBody>
+                  <a:tcPr marL="73152" marR="73152" marT="73152" marB="73152" anchor="ctr">
+                    <a:lnL w="6350" cap="flat" cmpd="sng" algn="ctr">
+                      <a:solidFill>
+                        <a:srgbClr val="DDE2EA"/>
+                      </a:solidFill>
+                      <a:prstDash val="solid"/>
+                      <a:round/>
+                      <a:headEnd type="none" w="med" len="med"/>
+                      <a:tailEnd type="none" w="med" len="med"/>
+                    </a:lnL>
+                    <a:lnR w="6350" cap="flat" cmpd="sng" algn="ctr">
+                      <a:solidFill>
+                        <a:srgbClr val="DDE2EA"/>
+                      </a:solidFill>
+                      <a:prstDash val="solid"/>
+                      <a:round/>
+                      <a:headEnd type="none" w="med" len="med"/>
+                      <a:tailEnd type="none" w="med" len="med"/>
+                    </a:lnR>
+                    <a:lnT w="6350" cap="flat" cmpd="sng" algn="ctr">
+                      <a:solidFill>
+                        <a:srgbClr val="DDE2EA"/>
+                      </a:solidFill>
+                      <a:prstDash val="solid"/>
+                      <a:round/>
+                      <a:headEnd type="none" w="med" len="med"/>
+                      <a:tailEnd type="none" w="med" len="med"/>
+                    </a:lnT>
+                    <a:lnB w="6350" cap="flat" cmpd="sng" algn="ctr">
+                      <a:solidFill>
+                        <a:srgbClr val="DDE2EA"/>
+                      </a:solidFill>
+                      <a:prstDash val="solid"/>
+                      <a:round/>
+                      <a:headEnd type="none" w="med" len="med"/>
+                      <a:tailEnd type="none" w="med" len="med"/>
+                    </a:lnB>
+                    <a:solidFill>
+                      <a:srgbClr val="FFFFFF"/>
+                    </a:solidFill>
+                  </a:tcPr>
+                </a:tc>
+                <a:tc>
+                  <a:txBody>
+                    <a:bodyPr/>
+                    <a:lstStyle/>
+                    <a:p>
+                      <a:pPr indent="0" marL="0">
+                        <a:buNone/>
+                      </a:pPr>
+                      <a:r>
+                        <a:rPr lang="en-US" sz="1250" dirty="0">
+                          <a:solidFill>
+                            <a:srgbClr val="141A22"/>
+                          </a:solidFill>
+                          <a:latin typeface="+mn-lt" pitchFamily="34" charset="0"/>
+                          <a:ea typeface="+mn-lt" pitchFamily="34" charset="-122"/>
+                          <a:cs typeface="+mn-lt" pitchFamily="34" charset="-120"/>
+                        </a:rPr>
+                        <a:t>Next: expiring grants and notifications (slide 8)</a:t>
+                      </a:r>
+                      <a:endParaRPr lang="en-US" sz="1250" dirty="0">
+                        <a:latin typeface="+mn-lt" charset="0"/>
+                        <a:ea typeface="+mn-lt" charset="0"/>
+                        <a:cs typeface="+mn-lt" charset="0"/>
+                      </a:endParaRPr>
+                    </a:p>
+                  </a:txBody>
+                  <a:tcPr marL="73152" marR="73152" marT="73152" marB="73152" anchor="ctr">
+                    <a:lnL w="6350" cap="flat" cmpd="sng" algn="ctr">
+                      <a:solidFill>
+                        <a:srgbClr val="DDE2EA"/>
+                      </a:solidFill>
+                      <a:prstDash val="solid"/>
+                      <a:round/>
+                      <a:headEnd type="none" w="med" len="med"/>
+                      <a:tailEnd type="none" w="med" len="med"/>
+                    </a:lnL>
+                    <a:lnR w="6350" cap="flat" cmpd="sng" algn="ctr">
+                      <a:solidFill>
+                        <a:srgbClr val="DDE2EA"/>
+                      </a:solidFill>
+                      <a:prstDash val="solid"/>
+                      <a:round/>
+                      <a:headEnd type="none" w="med" len="med"/>
+                      <a:tailEnd type="none" w="med" len="med"/>
+                    </a:lnR>
+                    <a:lnT w="6350" cap="flat" cmpd="sng" algn="ctr">
+                      <a:solidFill>
+                        <a:srgbClr val="DDE2EA"/>
+                      </a:solidFill>
+                      <a:prstDash val="solid"/>
+                      <a:round/>
+                      <a:headEnd type="none" w="med" len="med"/>
+                      <a:tailEnd type="none" w="med" len="med"/>
+                    </a:lnT>
+                    <a:lnB w="6350" cap="flat" cmpd="sng" algn="ctr">
+                      <a:solidFill>
+                        <a:srgbClr val="DDE2EA"/>
+                      </a:solidFill>
+                      <a:prstDash val="solid"/>
+                      <a:round/>
+                      <a:headEnd type="none" w="med" len="med"/>
+                      <a:tailEnd type="none" w="med" len="med"/>
+                    </a:lnB>
+                    <a:solidFill>
+                      <a:srgbClr val="FFFFFF"/>
+                    </a:solidFill>
+                  </a:tcPr>
+                </a:tc>
+                <a:tc>
+                  <a:txBody>
+                    <a:bodyPr/>
+                    <a:lstStyle/>
+                    <a:p>
+                      <a:pPr indent="0" marL="0">
+                        <a:buNone/>
+                      </a:pPr>
+                      <a:r>
+                        <a:rPr lang="en-US" sz="1250" b="1" dirty="0">
+                          <a:solidFill>
+                            <a:srgbClr val="6B7280"/>
+                          </a:solidFill>
+                          <a:latin typeface="+mn-lt" pitchFamily="34" charset="0"/>
+                          <a:ea typeface="+mn-lt" pitchFamily="34" charset="-122"/>
+                          <a:cs typeface="+mn-lt" pitchFamily="34" charset="-120"/>
+                        </a:rPr>
+                        <a:t>Next</a:t>
+                      </a:r>
+                      <a:endParaRPr lang="en-US" sz="1250" dirty="0">
+                        <a:latin typeface="+mn-lt" charset="0"/>
+                        <a:ea typeface="+mn-lt" charset="0"/>
+                        <a:cs typeface="+mn-lt" charset="0"/>
+                      </a:endParaRPr>
+                    </a:p>
+                  </a:txBody>
+                  <a:tcPr marL="73152" marR="73152" marT="73152" marB="73152" anchor="ctr">
+                    <a:lnL w="6350" cap="flat" cmpd="sng" algn="ctr">
+                      <a:solidFill>
+                        <a:srgbClr val="DDE2EA"/>
+                      </a:solidFill>
+                      <a:prstDash val="solid"/>
+                      <a:round/>
+                      <a:headEnd type="none" w="med" len="med"/>
+                      <a:tailEnd type="none" w="med" len="med"/>
+                    </a:lnL>
+                    <a:lnR w="6350" cap="flat" cmpd="sng" algn="ctr">
+                      <a:solidFill>
+                        <a:srgbClr val="DDE2EA"/>
+                      </a:solidFill>
+                      <a:prstDash val="solid"/>
+                      <a:round/>
+                      <a:headEnd type="none" w="med" len="med"/>
+                      <a:tailEnd type="none" w="med" len="med"/>
+                    </a:lnR>
+                    <a:lnT w="6350" cap="flat" cmpd="sng" algn="ctr">
+                      <a:solidFill>
+                        <a:srgbClr val="DDE2EA"/>
+                      </a:solidFill>
+                      <a:prstDash val="solid"/>
+                      <a:round/>
+                      <a:headEnd type="none" w="med" len="med"/>
+                      <a:tailEnd type="none" w="med" len="med"/>
+                    </a:lnT>
+                    <a:lnB w="6350" cap="flat" cmpd="sng" algn="ctr">
+                      <a:solidFill>
+                        <a:srgbClr val="DDE2EA"/>
+                      </a:solidFill>
+                      <a:prstDash val="solid"/>
+                      <a:round/>
+                      <a:headEnd type="none" w="med" len="med"/>
+                      <a:tailEnd type="none" w="med" len="med"/>
+                    </a:lnB>
+                    <a:solidFill>
+                      <a:srgbClr val="FFFFFF"/>
+                    </a:solidFill>
+                  </a:tcPr>
+                </a:tc>
+              </a:tr>
+            </a:tbl>
+          </a:graphicData>
+        </a:graphic>
+      </p:graphicFrame>
+      <p:sp>
+        <p:nvSpPr>
+          <p:cNvPr id="4" name="crit 0"/>
           <p:cNvSpPr/>
           <p:nvPr/>
         </p:nvSpPr>
         <p:spPr>
           <a:xfrm>
-            <a:off x="822960" y="1554480"/>
-            <a:ext cx="3383280" cy="2286000"/>
+            <a:off x="822960" y="4983480"/>
+            <a:ext cx="2029968" cy="1188720"/>
           </a:xfrm>
           <a:prstGeom prst="roundRect">
             <a:avLst>
-              <a:gd name="adj" fmla="val 5600"/>
+              <a:gd name="adj" fmla="val 9231"/>
             </a:avLst>
           </a:prstGeom>
           <a:solidFill>
@@ -5295,14 +6846,50 @@
       </p:sp>
       <p:sp>
         <p:nvSpPr>
-          <p:cNvPr id="4" name="panel head Expiring access"/>
+          <p:cNvPr id="5" name="crit head 0"/>
           <p:cNvSpPr txBox="1"/>
           <p:nvPr/>
         </p:nvSpPr>
         <p:spPr>
           <a:xfrm>
-            <a:off x="1097280" y="1783080"/>
-            <a:ext cx="2834640" cy="731520"/>
+            <a:off x="987552" y="5074920"/>
+            <a:ext cx="1737360" cy="320040"/>
+          </a:xfrm>
+          <a:prstGeom prst="rect">
+            <a:avLst/>
+          </a:prstGeom>
+          <a:noFill/>
+          <a:ln/>
+        </p:spPr>
+        <p:txBody>
+          <a:bodyPr wrap="square" lIns="0" tIns="0" rIns="0" bIns="0" rtlCol="0" anchor="ctr"/>
+          <a:lstStyle/>
+          <a:p>
+            <a:pPr indent="0" marL="0">
+              <a:buNone/>
+            </a:pPr>
+            <a:r>
+              <a:rPr lang="en-US" sz="1250" b="1" dirty="0">
+                <a:solidFill>
+                  <a:srgbClr val="3451D1"/>
+                </a:solidFill>
+              </a:rPr>
+              <a:t>Governance 25%</a:t>
+            </a:r>
+            <a:endParaRPr lang="en-US" sz="1250" dirty="0"/>
+          </a:p>
+        </p:txBody>
+      </p:sp>
+      <p:sp>
+        <p:nvSpPr>
+          <p:cNvPr id="6" name="crit body 0"/>
+          <p:cNvSpPr txBox="1"/>
+          <p:nvPr/>
+        </p:nvSpPr>
+        <p:spPr>
+          <a:xfrm>
+            <a:off x="987552" y="5394960"/>
+            <a:ext cx="1737360" cy="731520"/>
           </a:xfrm>
           <a:prstGeom prst="rect">
             <a:avLst/>
@@ -5318,67 +6905,31 @@
               <a:buNone/>
             </a:pPr>
             <a:r>
-              <a:rPr lang="en-US" sz="1800" b="1" dirty="0">
+              <a:rPr lang="en-US" sz="1100" dirty="0">
                 <a:solidFill>
                   <a:srgbClr val="141A22"/>
                 </a:solidFill>
               </a:rPr>
-              <a:t>Expiring access</a:t>
-            </a:r>
-            <a:endParaRPr lang="en-US" sz="1800" dirty="0"/>
-          </a:p>
-        </p:txBody>
-      </p:sp>
-      <p:sp>
-        <p:nvSpPr>
-          <p:cNvPr id="5" name="panel body Expiring access"/>
-          <p:cNvSpPr txBox="1"/>
-          <p:nvPr/>
-        </p:nvSpPr>
-        <p:spPr>
-          <a:xfrm>
-            <a:off x="1097280" y="2560320"/>
-            <a:ext cx="2834640" cy="1097280"/>
-          </a:xfrm>
-          <a:prstGeom prst="rect">
-            <a:avLst/>
-          </a:prstGeom>
-          <a:noFill/>
-          <a:ln/>
-        </p:spPr>
-        <p:txBody>
-          <a:bodyPr wrap="square" lIns="0" tIns="0" rIns="0" bIns="0" rtlCol="0" anchor="t"/>
-          <a:lstStyle/>
-          <a:p>
-            <a:pPr indent="0" marL="0">
-              <a:buNone/>
-            </a:pPr>
-            <a:r>
-              <a:rPr lang="en-US" sz="1500" dirty="0">
-                <a:solidFill>
-                  <a:srgbClr val="141A22"/>
-                </a:solidFill>
-              </a:rPr>
-              <a:t>Grants with an end date and a scheduled revoke, so entitlements never outlive the project.</a:t>
-            </a:r>
-            <a:endParaRPr lang="en-US" sz="1500" dirty="0"/>
-          </a:p>
-        </p:txBody>
-      </p:sp>
-      <p:sp>
-        <p:nvSpPr>
-          <p:cNvPr id="6" name="panel Notify the owner"/>
+              <a:t>Real grant, owner-only, nothing hidden</a:t>
+            </a:r>
+            <a:endParaRPr lang="en-US" sz="1100" dirty="0"/>
+          </a:p>
+        </p:txBody>
+      </p:sp>
+      <p:sp>
+        <p:nvSpPr>
+          <p:cNvPr id="7" name="crit 1"/>
           <p:cNvSpPr/>
           <p:nvPr/>
         </p:nvSpPr>
         <p:spPr>
           <a:xfrm>
-            <a:off x="4389120" y="1554480"/>
-            <a:ext cx="3383280" cy="2286000"/>
+            <a:off x="2962656" y="4983480"/>
+            <a:ext cx="2029968" cy="1188720"/>
           </a:xfrm>
           <a:prstGeom prst="roundRect">
             <a:avLst>
-              <a:gd name="adj" fmla="val 5600"/>
+              <a:gd name="adj" fmla="val 9231"/>
             </a:avLst>
           </a:prstGeom>
           <a:solidFill>
@@ -5394,14 +6945,50 @@
       </p:sp>
       <p:sp>
         <p:nvSpPr>
-          <p:cNvPr id="7" name="panel head Notify the owner"/>
+          <p:cNvPr id="8" name="crit head 1"/>
           <p:cNvSpPr txBox="1"/>
           <p:nvPr/>
         </p:nvSpPr>
         <p:spPr>
           <a:xfrm>
-            <a:off x="4663440" y="1783080"/>
-            <a:ext cx="2834640" cy="731520"/>
+            <a:off x="3127248" y="5074920"/>
+            <a:ext cx="1737360" cy="320040"/>
+          </a:xfrm>
+          <a:prstGeom prst="rect">
+            <a:avLst/>
+          </a:prstGeom>
+          <a:noFill/>
+          <a:ln/>
+        </p:spPr>
+        <p:txBody>
+          <a:bodyPr wrap="square" lIns="0" tIns="0" rIns="0" bIns="0" rtlCol="0" anchor="ctr"/>
+          <a:lstStyle/>
+          <a:p>
+            <a:pPr indent="0" marL="0">
+              <a:buNone/>
+            </a:pPr>
+            <a:r>
+              <a:rPr lang="en-US" sz="1250" b="1" dirty="0">
+                <a:solidFill>
+                  <a:srgbClr val="3451D1"/>
+                </a:solidFill>
+              </a:rPr>
+              <a:t>Reusability 25%</a:t>
+            </a:r>
+            <a:endParaRPr lang="en-US" sz="1250" dirty="0"/>
+          </a:p>
+        </p:txBody>
+      </p:sp>
+      <p:sp>
+        <p:nvSpPr>
+          <p:cNvPr id="9" name="crit body 1"/>
+          <p:cNvSpPr txBox="1"/>
+          <p:nvPr/>
+        </p:nvSpPr>
+        <p:spPr>
+          <a:xfrm>
+            <a:off x="3127248" y="5394960"/>
+            <a:ext cx="1737360" cy="731520"/>
           </a:xfrm>
           <a:prstGeom prst="rect">
             <a:avLst/>
@@ -5417,67 +7004,31 @@
               <a:buNone/>
             </a:pPr>
             <a:r>
-              <a:rPr lang="en-US" sz="1800" b="1" dirty="0">
+              <a:rPr lang="en-US" sz="1100" dirty="0">
                 <a:solidFill>
                   <a:srgbClr val="141A22"/>
                 </a:solidFill>
               </a:rPr>
-              <a:t>Notify the owner</a:t>
-            </a:r>
-            <a:endParaRPr lang="en-US" sz="1800" dirty="0"/>
-          </a:p>
-        </p:txBody>
-      </p:sp>
-      <p:sp>
-        <p:nvSpPr>
-          <p:cNvPr id="8" name="panel body Notify the owner"/>
-          <p:cNvSpPr txBox="1"/>
-          <p:nvPr/>
-        </p:nvSpPr>
-        <p:spPr>
-          <a:xfrm>
-            <a:off x="4663440" y="2560320"/>
-            <a:ext cx="2834640" cy="1097280"/>
-          </a:xfrm>
-          <a:prstGeom prst="rect">
-            <a:avLst/>
-          </a:prstGeom>
-          <a:noFill/>
-          <a:ln/>
-        </p:spPr>
-        <p:txBody>
-          <a:bodyPr wrap="square" lIns="0" tIns="0" rIns="0" bIns="0" rtlCol="0" anchor="t"/>
-          <a:lstStyle/>
-          <a:p>
-            <a:pPr indent="0" marL="0">
-              <a:buNone/>
-            </a:pPr>
-            <a:r>
-              <a:rPr lang="en-US" sz="1500" dirty="0">
-                <a:solidFill>
-                  <a:srgbClr val="141A22"/>
-                </a:solidFill>
-              </a:rPr>
-              <a:t>Teams or email on request and on decision; the queue comes to you.</a:t>
-            </a:r>
-            <a:endParaRPr lang="en-US" sz="1500" dirty="0"/>
-          </a:p>
-        </p:txBody>
-      </p:sp>
-      <p:sp>
-        <p:nvSpPr>
-          <p:cNvPr id="9" name="panel Chargeback"/>
+              <a:t>Tag a table, it appears; no code</a:t>
+            </a:r>
+            <a:endParaRPr lang="en-US" sz="1100" dirty="0"/>
+          </a:p>
+        </p:txBody>
+      </p:sp>
+      <p:sp>
+        <p:nvSpPr>
+          <p:cNvPr id="10" name="crit 2"/>
           <p:cNvSpPr/>
           <p:nvPr/>
         </p:nvSpPr>
         <p:spPr>
           <a:xfrm>
-            <a:off x="7955280" y="1554480"/>
-            <a:ext cx="3383280" cy="2286000"/>
+            <a:off x="5102352" y="4983480"/>
+            <a:ext cx="2029968" cy="1188720"/>
           </a:xfrm>
           <a:prstGeom prst="roundRect">
             <a:avLst>
-              <a:gd name="adj" fmla="val 5600"/>
+              <a:gd name="adj" fmla="val 9231"/>
             </a:avLst>
           </a:prstGeom>
           <a:solidFill>
@@ -5493,14 +7044,50 @@
       </p:sp>
       <p:sp>
         <p:nvSpPr>
-          <p:cNvPr id="10" name="panel head Chargeback"/>
+          <p:cNvPr id="11" name="crit head 2"/>
           <p:cNvSpPr txBox="1"/>
           <p:nvPr/>
         </p:nvSpPr>
         <p:spPr>
           <a:xfrm>
-            <a:off x="8229600" y="1783080"/>
-            <a:ext cx="2834640" cy="731520"/>
+            <a:off x="5266944" y="5074920"/>
+            <a:ext cx="1737360" cy="320040"/>
+          </a:xfrm>
+          <a:prstGeom prst="rect">
+            <a:avLst/>
+          </a:prstGeom>
+          <a:noFill/>
+          <a:ln/>
+        </p:spPr>
+        <p:txBody>
+          <a:bodyPr wrap="square" lIns="0" tIns="0" rIns="0" bIns="0" rtlCol="0" anchor="ctr"/>
+          <a:lstStyle/>
+          <a:p>
+            <a:pPr indent="0" marL="0">
+              <a:buNone/>
+            </a:pPr>
+            <a:r>
+              <a:rPr lang="en-US" sz="1250" b="1" dirty="0">
+                <a:solidFill>
+                  <a:srgbClr val="3451D1"/>
+                </a:solidFill>
+              </a:rPr>
+              <a:t>Self-service 25%</a:t>
+            </a:r>
+            <a:endParaRPr lang="en-US" sz="1250" dirty="0"/>
+          </a:p>
+        </p:txBody>
+      </p:sp>
+      <p:sp>
+        <p:nvSpPr>
+          <p:cNvPr id="12" name="crit body 2"/>
+          <p:cNvSpPr txBox="1"/>
+          <p:nvPr/>
+        </p:nvSpPr>
+        <p:spPr>
+          <a:xfrm>
+            <a:off x="5266944" y="5394960"/>
+            <a:ext cx="1737360" cy="731520"/>
           </a:xfrm>
           <a:prstGeom prst="rect">
             <a:avLst/>
@@ -5516,27 +7103,90 @@
               <a:buNone/>
             </a:pPr>
             <a:r>
-              <a:rPr lang="en-US" sz="1800" b="1" dirty="0">
+              <a:rPr lang="en-US" sz="1100" dirty="0">
                 <a:solidFill>
                   <a:srgbClr val="141A22"/>
                 </a:solidFill>
               </a:rPr>
-              <a:t>Chargeback</a:t>
-            </a:r>
-            <a:endParaRPr lang="en-US" sz="1800" dirty="0"/>
-          </a:p>
-        </p:txBody>
-      </p:sp>
-      <p:sp>
-        <p:nvSpPr>
-          <p:cNvPr id="11" name="panel body Chargeback"/>
+              <a:t>No ticket: ask, see status, download</a:t>
+            </a:r>
+            <a:endParaRPr lang="en-US" sz="1100" dirty="0"/>
+          </a:p>
+        </p:txBody>
+      </p:sp>
+      <p:sp>
+        <p:nvSpPr>
+          <p:cNvPr id="13" name="crit 3"/>
+          <p:cNvSpPr/>
+          <p:nvPr/>
+        </p:nvSpPr>
+        <p:spPr>
+          <a:xfrm>
+            <a:off x="7242048" y="4983480"/>
+            <a:ext cx="2029968" cy="1188720"/>
+          </a:xfrm>
+          <a:prstGeom prst="roundRect">
+            <a:avLst>
+              <a:gd name="adj" fmla="val 9231"/>
+            </a:avLst>
+          </a:prstGeom>
+          <a:solidFill>
+            <a:srgbClr val="F3F5F9"/>
+          </a:solidFill>
+          <a:ln w="12700">
+            <a:solidFill>
+              <a:srgbClr val="F3F5F9"/>
+            </a:solidFill>
+            <a:prstDash val="solid"/>
+          </a:ln>
+        </p:spPr>
+      </p:sp>
+      <p:sp>
+        <p:nvSpPr>
+          <p:cNvPr id="14" name="crit head 3"/>
           <p:cNvSpPr txBox="1"/>
           <p:nvPr/>
         </p:nvSpPr>
         <p:spPr>
           <a:xfrm>
-            <a:off x="8229600" y="2560320"/>
-            <a:ext cx="2834640" cy="1097280"/>
+            <a:off x="7406640" y="5074920"/>
+            <a:ext cx="1737360" cy="320040"/>
+          </a:xfrm>
+          <a:prstGeom prst="rect">
+            <a:avLst/>
+          </a:prstGeom>
+          <a:noFill/>
+          <a:ln/>
+        </p:spPr>
+        <p:txBody>
+          <a:bodyPr wrap="square" lIns="0" tIns="0" rIns="0" bIns="0" rtlCol="0" anchor="ctr"/>
+          <a:lstStyle/>
+          <a:p>
+            <a:pPr indent="0" marL="0">
+              <a:buNone/>
+            </a:pPr>
+            <a:r>
+              <a:rPr lang="en-US" sz="1250" b="1" dirty="0">
+                <a:solidFill>
+                  <a:srgbClr val="3451D1"/>
+                </a:solidFill>
+              </a:rPr>
+              <a:t>Polish 15%</a:t>
+            </a:r>
+            <a:endParaRPr lang="en-US" sz="1250" dirty="0"/>
+          </a:p>
+        </p:txBody>
+      </p:sp>
+      <p:sp>
+        <p:nvSpPr>
+          <p:cNvPr id="15" name="crit body 3"/>
+          <p:cNvSpPr txBox="1"/>
+          <p:nvPr/>
+        </p:nvSpPr>
+        <p:spPr>
+          <a:xfrm>
+            <a:off x="7406640" y="5394960"/>
+            <a:ext cx="1737360" cy="731520"/>
           </a:xfrm>
           <a:prstGeom prst="rect">
             <a:avLst/>
@@ -5552,27 +7202,54 @@
               <a:buNone/>
             </a:pPr>
             <a:r>
-              <a:rPr lang="en-US" sz="1500" dirty="0">
+              <a:rPr lang="en-US" sz="1100" dirty="0">
                 <a:solidFill>
                   <a:srgbClr val="141A22"/>
                 </a:solidFill>
               </a:rPr>
-              <a:t>Licence spend by desk and cost centre, straight from the audit table.</a:t>
-            </a:r>
-            <a:endParaRPr lang="en-US" sz="1500" dirty="0"/>
-          </a:p>
-        </p:txBody>
-      </p:sp>
-      <p:sp>
-        <p:nvSpPr>
-          <p:cNvPr id="12" name="team head"/>
+              <a:t>One accent, one card, one reason</a:t>
+            </a:r>
+            <a:endParaRPr lang="en-US" sz="1100" dirty="0"/>
+          </a:p>
+        </p:txBody>
+      </p:sp>
+      <p:sp>
+        <p:nvSpPr>
+          <p:cNvPr id="16" name="crit 4"/>
+          <p:cNvSpPr/>
+          <p:nvPr/>
+        </p:nvSpPr>
+        <p:spPr>
+          <a:xfrm>
+            <a:off x="9381744" y="4983480"/>
+            <a:ext cx="2029968" cy="1188720"/>
+          </a:xfrm>
+          <a:prstGeom prst="roundRect">
+            <a:avLst>
+              <a:gd name="adj" fmla="val 9231"/>
+            </a:avLst>
+          </a:prstGeom>
+          <a:solidFill>
+            <a:srgbClr val="F3F5F9"/>
+          </a:solidFill>
+          <a:ln w="12700">
+            <a:solidFill>
+              <a:srgbClr val="F3F5F9"/>
+            </a:solidFill>
+            <a:prstDash val="solid"/>
+          </a:ln>
+        </p:spPr>
+      </p:sp>
+      <p:sp>
+        <p:nvSpPr>
+          <p:cNvPr id="17" name="crit head 4"/>
           <p:cNvSpPr txBox="1"/>
           <p:nvPr/>
         </p:nvSpPr>
         <p:spPr>
           <a:xfrm>
-            <a:off x="822960" y="4297680"/>
-            <a:ext cx="4572000" cy="457200"/>
+            <a:off x="9546336" y="5074920"/>
+            <a:ext cx="1737360" cy="320040"/>
           </a:xfrm>
           <a:prstGeom prst="rect">
             <a:avLst/>
@@ -5588,100 +7265,50 @@
               <a:buNone/>
             </a:pPr>
             <a:r>
-              <a:rPr lang="en-US" sz="2000" b="1" dirty="0">
+              <a:rPr lang="en-US" sz="1250" b="1" dirty="0">
+                <a:solidFill>
+                  <a:srgbClr val="3451D1"/>
+                </a:solidFill>
+              </a:rPr>
+              <a:t>Innovation 10%</a:t>
+            </a:r>
+            <a:endParaRPr lang="en-US" sz="1250" dirty="0"/>
+          </a:p>
+        </p:txBody>
+      </p:sp>
+      <p:sp>
+        <p:nvSpPr>
+          <p:cNvPr id="18" name="crit body 4"/>
+          <p:cNvSpPr txBox="1"/>
+          <p:nvPr/>
+        </p:nvSpPr>
+        <p:spPr>
+          <a:xfrm>
+            <a:off x="9546336" y="5394960"/>
+            <a:ext cx="1737360" cy="731520"/>
+          </a:xfrm>
+          <a:prstGeom prst="rect">
+            <a:avLst/>
+          </a:prstGeom>
+          <a:noFill/>
+          <a:ln/>
+        </p:spPr>
+        <p:txBody>
+          <a:bodyPr wrap="square" lIns="0" tIns="0" rIns="0" bIns="0" rtlCol="0" anchor="t"/>
+          <a:lstStyle/>
+          <a:p>
+            <a:pPr indent="0" marL="0">
+              <a:buNone/>
+            </a:pPr>
+            <a:r>
+              <a:rPr lang="en-US" sz="1100" dirty="0">
                 <a:solidFill>
                   <a:srgbClr val="141A22"/>
                 </a:solidFill>
               </a:rPr>
-              <a:t>Team Sierra</a:t>
-            </a:r>
-            <a:endParaRPr lang="en-US" sz="2000" dirty="0"/>
-          </a:p>
-        </p:txBody>
-      </p:sp>
-      <p:sp>
-        <p:nvSpPr>
-          <p:cNvPr id="13" name="team body"/>
-          <p:cNvSpPr txBox="1"/>
-          <p:nvPr/>
-        </p:nvSpPr>
-        <p:spPr>
-          <a:xfrm>
-            <a:off x="822960" y="4800600"/>
-            <a:ext cx="10515600" cy="822960"/>
-          </a:xfrm>
-          <a:prstGeom prst="rect">
-            <a:avLst/>
-          </a:prstGeom>
-          <a:noFill/>
-          <a:ln/>
-        </p:spPr>
-        <p:txBody>
-          <a:bodyPr wrap="square" lIns="0" tIns="0" rIns="0" bIns="0" rtlCol="0" anchor="ctr"/>
-          <a:lstStyle/>
-          <a:p>
-            <a:pPr indent="0" marL="0">
-              <a:buNone/>
-            </a:pPr>
-            <a:r>
-              <a:rPr lang="en-US" sz="1400" dirty="0">
-                <a:solidFill>
-                  <a:srgbClr val="6B7280"/>
-                </a:solidFill>
-              </a:rPr>
-              <a:t>Jose and Malik, front end  ·  Younis and Patrick, data, governance and platform</a:t>
-            </a:r>
-            <a:endParaRPr lang="en-US" sz="1400" dirty="0"/>
-          </a:p>
-          <a:p>
-            <a:pPr indent="0" marL="0">
-              <a:buNone/>
-            </a:pPr>
-            <a:r>
-              <a:rPr lang="en-US" sz="1400" dirty="0">
-                <a:solidFill>
-                  <a:srgbClr val="6B7280"/>
-                </a:solidFill>
-              </a:rPr>
-              <a:t>Databricks Apps, Unity Catalog, Genie, ai_classify. Built with Codex and Claude Code.</a:t>
-            </a:r>
-            <a:endParaRPr lang="en-US" sz="1400" dirty="0"/>
-          </a:p>
-        </p:txBody>
-      </p:sp>
-      <p:sp>
-        <p:nvSpPr>
-          <p:cNvPr id="14" name="repo"/>
-          <p:cNvSpPr txBox="1"/>
-          <p:nvPr/>
-        </p:nvSpPr>
-        <p:spPr>
-          <a:xfrm>
-            <a:off x="822960" y="5669280"/>
-            <a:ext cx="7315200" cy="365760"/>
-          </a:xfrm>
-          <a:prstGeom prst="rect">
-            <a:avLst/>
-          </a:prstGeom>
-          <a:noFill/>
-          <a:ln/>
-        </p:spPr>
-        <p:txBody>
-          <a:bodyPr wrap="square" lIns="0" tIns="0" rIns="0" bIns="0" rtlCol="0" anchor="ctr"/>
-          <a:lstStyle/>
-          <a:p>
-            <a:pPr indent="0" marL="0">
-              <a:buNone/>
-            </a:pPr>
-            <a:r>
-              <a:rPr lang="en-US" sz="1400" dirty="0">
-                <a:solidFill>
-                  <a:srgbClr val="3451D1"/>
-                </a:solidFill>
-              </a:rPr>
-              <a:t>github.com/younis-y/desk-data-access</a:t>
-            </a:r>
-            <a:endParaRPr lang="en-US" sz="1400" dirty="0"/>
+              <a:t>Genie on the audit trail, ai_classify on reasons</a:t>
+            </a:r>
+            <a:endParaRPr lang="en-US" sz="1100" dirty="0"/>
           </a:p>
         </p:txBody>
       </p:sp>
@@ -5725,6 +7352,533 @@
             <a:fld id="{F7021451-1387-4CA6-816F-3879F97B5CBC}" type="slidenum">
               <a:rPr b="0" lang="en-US"/>
               <a:t>7</a:t>
+            </a:fld>
+            <a:endParaRPr lang="en-US"/>
+          </a:p>
+        </p:txBody>
+      </p:sp>
+    </p:spTree>
+  </p:cSld>
+  <p:clrMapOvr>
+    <a:masterClrMapping/>
+  </p:clrMapOvr>
+</p:sld>
+</file>
+
+<file path=ppt/slides/slide8.xml><?xml version="1.0" encoding="utf-8"?>
+<p:sld xmlns:a="http://schemas.openxmlformats.org/drawingml/2006/main" xmlns:r="http://schemas.openxmlformats.org/officeDocument/2006/relationships" xmlns:p="http://schemas.openxmlformats.org/presentationml/2006/main">
+  <p:cSld name="Slide 8">
+    <p:spTree>
+      <p:nvGrpSpPr>
+        <p:cNvPr id="1" name=""/>
+        <p:cNvGrpSpPr/>
+        <p:nvPr/>
+      </p:nvGrpSpPr>
+      <p:grpSpPr>
+        <a:xfrm>
+          <a:off x="0" y="0"/>
+          <a:ext cx="0" cy="0"/>
+          <a:chOff x="0" y="0"/>
+          <a:chExt cx="0" cy="0"/>
+        </a:xfrm>
+      </p:grpSpPr>
+      <p:sp>
+        <p:nvSpPr>
+          <p:cNvPr id="2" name="Text 0"/>
+          <p:cNvSpPr/>
+          <p:nvPr>
+            <p:ph idx="100" type="title" hasCustomPrompt="1"/>
+          </p:nvPr>
+        </p:nvSpPr>
+        <p:spPr>
+          <a:xfrm>
+            <a:off x="822960" y="457200"/>
+            <a:ext cx="10515600" cy="868680"/>
+          </a:xfrm>
+          <a:prstGeom prst="rect">
+            <a:avLst/>
+          </a:prstGeom>
+          <a:noFill/>
+          <a:ln/>
+        </p:spPr>
+        <p:txBody>
+          <a:bodyPr wrap="square" lIns="0" tIns="0" rIns="0" bIns="0" rtlCol="0"/>
+          <a:lstStyle/>
+          <a:p>
+            <a:pPr algn="l" indent="0" marL="0">
+              <a:buNone/>
+            </a:pPr>
+            <a:r>
+              <a:rPr lang="en-US" sz="3200" b="1" dirty="0">
+                <a:solidFill>
+                  <a:srgbClr val="141A22"/>
+                </a:solidFill>
+              </a:rPr>
+              <a:t>What comes next</a:t>
+            </a:r>
+            <a:endParaRPr lang="en-US" sz="3200" dirty="0"/>
+          </a:p>
+        </p:txBody>
+      </p:sp>
+      <p:sp>
+        <p:nvSpPr>
+          <p:cNvPr id="3" name="panel Expiring access"/>
+          <p:cNvSpPr/>
+          <p:nvPr/>
+        </p:nvSpPr>
+        <p:spPr>
+          <a:xfrm>
+            <a:off x="822960" y="1554480"/>
+            <a:ext cx="3383280" cy="2286000"/>
+          </a:xfrm>
+          <a:prstGeom prst="roundRect">
+            <a:avLst>
+              <a:gd name="adj" fmla="val 5600"/>
+            </a:avLst>
+          </a:prstGeom>
+          <a:solidFill>
+            <a:srgbClr val="F3F5F9"/>
+          </a:solidFill>
+          <a:ln w="12700">
+            <a:solidFill>
+              <a:srgbClr val="F3F5F9"/>
+            </a:solidFill>
+            <a:prstDash val="solid"/>
+          </a:ln>
+        </p:spPr>
+      </p:sp>
+      <p:sp>
+        <p:nvSpPr>
+          <p:cNvPr id="4" name="panel head Expiring access"/>
+          <p:cNvSpPr txBox="1"/>
+          <p:nvPr/>
+        </p:nvSpPr>
+        <p:spPr>
+          <a:xfrm>
+            <a:off x="1097280" y="1783080"/>
+            <a:ext cx="2834640" cy="731520"/>
+          </a:xfrm>
+          <a:prstGeom prst="rect">
+            <a:avLst/>
+          </a:prstGeom>
+          <a:noFill/>
+          <a:ln/>
+        </p:spPr>
+        <p:txBody>
+          <a:bodyPr wrap="square" lIns="0" tIns="0" rIns="0" bIns="0" rtlCol="0" anchor="t"/>
+          <a:lstStyle/>
+          <a:p>
+            <a:pPr indent="0" marL="0">
+              <a:buNone/>
+            </a:pPr>
+            <a:r>
+              <a:rPr lang="en-US" sz="1800" b="1" dirty="0">
+                <a:solidFill>
+                  <a:srgbClr val="141A22"/>
+                </a:solidFill>
+              </a:rPr>
+              <a:t>Expiring access</a:t>
+            </a:r>
+            <a:endParaRPr lang="en-US" sz="1800" dirty="0"/>
+          </a:p>
+        </p:txBody>
+      </p:sp>
+      <p:sp>
+        <p:nvSpPr>
+          <p:cNvPr id="5" name="panel body Expiring access"/>
+          <p:cNvSpPr txBox="1"/>
+          <p:nvPr/>
+        </p:nvSpPr>
+        <p:spPr>
+          <a:xfrm>
+            <a:off x="1097280" y="2560320"/>
+            <a:ext cx="2834640" cy="1097280"/>
+          </a:xfrm>
+          <a:prstGeom prst="rect">
+            <a:avLst/>
+          </a:prstGeom>
+          <a:noFill/>
+          <a:ln/>
+        </p:spPr>
+        <p:txBody>
+          <a:bodyPr wrap="square" lIns="0" tIns="0" rIns="0" bIns="0" rtlCol="0" anchor="t"/>
+          <a:lstStyle/>
+          <a:p>
+            <a:pPr indent="0" marL="0">
+              <a:buNone/>
+            </a:pPr>
+            <a:r>
+              <a:rPr lang="en-US" sz="1500" dirty="0">
+                <a:solidFill>
+                  <a:srgbClr val="141A22"/>
+                </a:solidFill>
+              </a:rPr>
+              <a:t>Grants with an end date and a scheduled revoke, so entitlements never outlive the project.</a:t>
+            </a:r>
+            <a:endParaRPr lang="en-US" sz="1500" dirty="0"/>
+          </a:p>
+        </p:txBody>
+      </p:sp>
+      <p:sp>
+        <p:nvSpPr>
+          <p:cNvPr id="6" name="panel Notify the owner"/>
+          <p:cNvSpPr/>
+          <p:nvPr/>
+        </p:nvSpPr>
+        <p:spPr>
+          <a:xfrm>
+            <a:off x="4389120" y="1554480"/>
+            <a:ext cx="3383280" cy="2286000"/>
+          </a:xfrm>
+          <a:prstGeom prst="roundRect">
+            <a:avLst>
+              <a:gd name="adj" fmla="val 5600"/>
+            </a:avLst>
+          </a:prstGeom>
+          <a:solidFill>
+            <a:srgbClr val="F3F5F9"/>
+          </a:solidFill>
+          <a:ln w="12700">
+            <a:solidFill>
+              <a:srgbClr val="F3F5F9"/>
+            </a:solidFill>
+            <a:prstDash val="solid"/>
+          </a:ln>
+        </p:spPr>
+      </p:sp>
+      <p:sp>
+        <p:nvSpPr>
+          <p:cNvPr id="7" name="panel head Notify the owner"/>
+          <p:cNvSpPr txBox="1"/>
+          <p:nvPr/>
+        </p:nvSpPr>
+        <p:spPr>
+          <a:xfrm>
+            <a:off x="4663440" y="1783080"/>
+            <a:ext cx="2834640" cy="731520"/>
+          </a:xfrm>
+          <a:prstGeom prst="rect">
+            <a:avLst/>
+          </a:prstGeom>
+          <a:noFill/>
+          <a:ln/>
+        </p:spPr>
+        <p:txBody>
+          <a:bodyPr wrap="square" lIns="0" tIns="0" rIns="0" bIns="0" rtlCol="0" anchor="t"/>
+          <a:lstStyle/>
+          <a:p>
+            <a:pPr indent="0" marL="0">
+              <a:buNone/>
+            </a:pPr>
+            <a:r>
+              <a:rPr lang="en-US" sz="1800" b="1" dirty="0">
+                <a:solidFill>
+                  <a:srgbClr val="141A22"/>
+                </a:solidFill>
+              </a:rPr>
+              <a:t>Notify the owner</a:t>
+            </a:r>
+            <a:endParaRPr lang="en-US" sz="1800" dirty="0"/>
+          </a:p>
+        </p:txBody>
+      </p:sp>
+      <p:sp>
+        <p:nvSpPr>
+          <p:cNvPr id="8" name="panel body Notify the owner"/>
+          <p:cNvSpPr txBox="1"/>
+          <p:nvPr/>
+        </p:nvSpPr>
+        <p:spPr>
+          <a:xfrm>
+            <a:off x="4663440" y="2560320"/>
+            <a:ext cx="2834640" cy="1097280"/>
+          </a:xfrm>
+          <a:prstGeom prst="rect">
+            <a:avLst/>
+          </a:prstGeom>
+          <a:noFill/>
+          <a:ln/>
+        </p:spPr>
+        <p:txBody>
+          <a:bodyPr wrap="square" lIns="0" tIns="0" rIns="0" bIns="0" rtlCol="0" anchor="t"/>
+          <a:lstStyle/>
+          <a:p>
+            <a:pPr indent="0" marL="0">
+              <a:buNone/>
+            </a:pPr>
+            <a:r>
+              <a:rPr lang="en-US" sz="1500" dirty="0">
+                <a:solidFill>
+                  <a:srgbClr val="141A22"/>
+                </a:solidFill>
+              </a:rPr>
+              <a:t>Teams or email on request and on decision; the queue comes to you.</a:t>
+            </a:r>
+            <a:endParaRPr lang="en-US" sz="1500" dirty="0"/>
+          </a:p>
+        </p:txBody>
+      </p:sp>
+      <p:sp>
+        <p:nvSpPr>
+          <p:cNvPr id="9" name="panel Chargeback"/>
+          <p:cNvSpPr/>
+          <p:nvPr/>
+        </p:nvSpPr>
+        <p:spPr>
+          <a:xfrm>
+            <a:off x="7955280" y="1554480"/>
+            <a:ext cx="3383280" cy="2286000"/>
+          </a:xfrm>
+          <a:prstGeom prst="roundRect">
+            <a:avLst>
+              <a:gd name="adj" fmla="val 5600"/>
+            </a:avLst>
+          </a:prstGeom>
+          <a:solidFill>
+            <a:srgbClr val="F3F5F9"/>
+          </a:solidFill>
+          <a:ln w="12700">
+            <a:solidFill>
+              <a:srgbClr val="F3F5F9"/>
+            </a:solidFill>
+            <a:prstDash val="solid"/>
+          </a:ln>
+        </p:spPr>
+      </p:sp>
+      <p:sp>
+        <p:nvSpPr>
+          <p:cNvPr id="10" name="panel head Chargeback"/>
+          <p:cNvSpPr txBox="1"/>
+          <p:nvPr/>
+        </p:nvSpPr>
+        <p:spPr>
+          <a:xfrm>
+            <a:off x="8229600" y="1783080"/>
+            <a:ext cx="2834640" cy="731520"/>
+          </a:xfrm>
+          <a:prstGeom prst="rect">
+            <a:avLst/>
+          </a:prstGeom>
+          <a:noFill/>
+          <a:ln/>
+        </p:spPr>
+        <p:txBody>
+          <a:bodyPr wrap="square" lIns="0" tIns="0" rIns="0" bIns="0" rtlCol="0" anchor="t"/>
+          <a:lstStyle/>
+          <a:p>
+            <a:pPr indent="0" marL="0">
+              <a:buNone/>
+            </a:pPr>
+            <a:r>
+              <a:rPr lang="en-US" sz="1800" b="1" dirty="0">
+                <a:solidFill>
+                  <a:srgbClr val="141A22"/>
+                </a:solidFill>
+              </a:rPr>
+              <a:t>Chargeback</a:t>
+            </a:r>
+            <a:endParaRPr lang="en-US" sz="1800" dirty="0"/>
+          </a:p>
+        </p:txBody>
+      </p:sp>
+      <p:sp>
+        <p:nvSpPr>
+          <p:cNvPr id="11" name="panel body Chargeback"/>
+          <p:cNvSpPr txBox="1"/>
+          <p:nvPr/>
+        </p:nvSpPr>
+        <p:spPr>
+          <a:xfrm>
+            <a:off x="8229600" y="2560320"/>
+            <a:ext cx="2834640" cy="1097280"/>
+          </a:xfrm>
+          <a:prstGeom prst="rect">
+            <a:avLst/>
+          </a:prstGeom>
+          <a:noFill/>
+          <a:ln/>
+        </p:spPr>
+        <p:txBody>
+          <a:bodyPr wrap="square" lIns="0" tIns="0" rIns="0" bIns="0" rtlCol="0" anchor="t"/>
+          <a:lstStyle/>
+          <a:p>
+            <a:pPr indent="0" marL="0">
+              <a:buNone/>
+            </a:pPr>
+            <a:r>
+              <a:rPr lang="en-US" sz="1500" dirty="0">
+                <a:solidFill>
+                  <a:srgbClr val="141A22"/>
+                </a:solidFill>
+              </a:rPr>
+              <a:t>Licence spend by desk and cost centre, straight from the audit table.</a:t>
+            </a:r>
+            <a:endParaRPr lang="en-US" sz="1500" dirty="0"/>
+          </a:p>
+        </p:txBody>
+      </p:sp>
+      <p:sp>
+        <p:nvSpPr>
+          <p:cNvPr id="12" name="team head"/>
+          <p:cNvSpPr txBox="1"/>
+          <p:nvPr/>
+        </p:nvSpPr>
+        <p:spPr>
+          <a:xfrm>
+            <a:off x="822960" y="4297680"/>
+            <a:ext cx="4572000" cy="457200"/>
+          </a:xfrm>
+          <a:prstGeom prst="rect">
+            <a:avLst/>
+          </a:prstGeom>
+          <a:noFill/>
+          <a:ln/>
+        </p:spPr>
+        <p:txBody>
+          <a:bodyPr wrap="square" lIns="0" tIns="0" rIns="0" bIns="0" rtlCol="0" anchor="ctr"/>
+          <a:lstStyle/>
+          <a:p>
+            <a:pPr indent="0" marL="0">
+              <a:buNone/>
+            </a:pPr>
+            <a:r>
+              <a:rPr lang="en-US" sz="2000" b="1" dirty="0">
+                <a:solidFill>
+                  <a:srgbClr val="141A22"/>
+                </a:solidFill>
+              </a:rPr>
+              <a:t>Team Sierra</a:t>
+            </a:r>
+            <a:endParaRPr lang="en-US" sz="2000" dirty="0"/>
+          </a:p>
+        </p:txBody>
+      </p:sp>
+      <p:sp>
+        <p:nvSpPr>
+          <p:cNvPr id="13" name="team body"/>
+          <p:cNvSpPr txBox="1"/>
+          <p:nvPr/>
+        </p:nvSpPr>
+        <p:spPr>
+          <a:xfrm>
+            <a:off x="822960" y="4800600"/>
+            <a:ext cx="10515600" cy="822960"/>
+          </a:xfrm>
+          <a:prstGeom prst="rect">
+            <a:avLst/>
+          </a:prstGeom>
+          <a:noFill/>
+          <a:ln/>
+        </p:spPr>
+        <p:txBody>
+          <a:bodyPr wrap="square" lIns="0" tIns="0" rIns="0" bIns="0" rtlCol="0" anchor="ctr"/>
+          <a:lstStyle/>
+          <a:p>
+            <a:pPr indent="0" marL="0">
+              <a:buNone/>
+            </a:pPr>
+            <a:r>
+              <a:rPr lang="en-US" sz="1400" dirty="0">
+                <a:solidFill>
+                  <a:srgbClr val="6B7280"/>
+                </a:solidFill>
+              </a:rPr>
+              <a:t>Jose and Malik, front end  ·  Younis and Patrick, data, governance and platform</a:t>
+            </a:r>
+            <a:endParaRPr lang="en-US" sz="1400" dirty="0"/>
+          </a:p>
+          <a:p>
+            <a:pPr indent="0" marL="0">
+              <a:buNone/>
+            </a:pPr>
+            <a:r>
+              <a:rPr lang="en-US" sz="1400" dirty="0">
+                <a:solidFill>
+                  <a:srgbClr val="6B7280"/>
+                </a:solidFill>
+              </a:rPr>
+              <a:t>Databricks Apps, Unity Catalog, Genie, ai_classify. Built with Codex and Claude Code.</a:t>
+            </a:r>
+            <a:endParaRPr lang="en-US" sz="1400" dirty="0"/>
+          </a:p>
+        </p:txBody>
+      </p:sp>
+      <p:sp>
+        <p:nvSpPr>
+          <p:cNvPr id="14" name="repo"/>
+          <p:cNvSpPr txBox="1"/>
+          <p:nvPr/>
+        </p:nvSpPr>
+        <p:spPr>
+          <a:xfrm>
+            <a:off x="822960" y="5669280"/>
+            <a:ext cx="7315200" cy="365760"/>
+          </a:xfrm>
+          <a:prstGeom prst="rect">
+            <a:avLst/>
+          </a:prstGeom>
+          <a:noFill/>
+          <a:ln/>
+        </p:spPr>
+        <p:txBody>
+          <a:bodyPr wrap="square" lIns="0" tIns="0" rIns="0" bIns="0" rtlCol="0" anchor="ctr"/>
+          <a:lstStyle/>
+          <a:p>
+            <a:pPr indent="0" marL="0">
+              <a:buNone/>
+            </a:pPr>
+            <a:r>
+              <a:rPr lang="en-US" sz="1400" dirty="0">
+                <a:solidFill>
+                  <a:srgbClr val="3451D1"/>
+                </a:solidFill>
+              </a:rPr>
+              <a:t>github.com/younis-y/desk-data-access</a:t>
+            </a:r>
+            <a:endParaRPr lang="en-US" sz="1400" dirty="0"/>
+          </a:p>
+        </p:txBody>
+      </p:sp>
+      <p:sp>
+        <p:nvSpPr>
+          <p:cNvPr id="25" name="Slide Number Placeholder 0"/>
+          <p:cNvSpPr>
+            <a:spLocks noGrp="1"/>
+          </p:cNvSpPr>
+          <p:nvPr>
+            <p:ph type="sldNum" sz="quarter" idx="4294967295"/>
+          </p:nvPr>
+        </p:nvSpPr>
+        <p:spPr>
+          <a:xfrm>
+            <a:off x="11247120" y="6400800"/>
+            <a:ext cx="457200" cy="274320"/>
+          </a:xfrm>
+          <a:prstGeom prst="rect">
+            <a:avLst/>
+          </a:prstGeom>
+          <a:extLst>
+            <a:ext uri="{C572A759-6A51-4108-AA02-DFA0A04FC94B}">
+              <ma14:wrappingTextBoxFlag xmlns:ma14="http://schemas.microsoft.com/office/mac/drawingml/2011/main" val="0"/>
+            </a:ext>
+          </a:extLst>
+        </p:spPr>
+        <p:txBody>
+          <a:bodyPr/>
+          <a:lstStyle>
+            <a:lvl1pPr>
+              <a:defRPr sz="1000">
+                <a:solidFill>
+                  <a:srgbClr val="6B7280"/>
+                </a:solidFill>
+              </a:defRPr>
+            </a:lvl1pPr>
+          </a:lstStyle>
+          <a:p>
+            <a:pPr algn="l"/>
+            <a:fld id="{F7021451-1387-4CA6-816F-3879F97B5CBC}" type="slidenum">
+              <a:rPr b="0" lang="en-US"/>
+              <a:t>8</a:t>
             </a:fld>
             <a:endParaRPr lang="en-US"/>
           </a:p>

</xml_diff>

<commit_message>
Deck: larger type, self-explanatory stats, layout fixes
Co-Authored-By: Claude Fable 5.1 <noreply@anthropic.com>
</commit_message>
<xml_diff>
--- a/docs/Doorman-deck.pptx
+++ b/docs/Doorman-deck.pptx
@@ -1284,7 +1284,7 @@
           <a:lstStyle>
             <a:lvl1pPr algn="l" indent="0" marL="0">
               <a:buNone/>
-              <a:defRPr lang="en-US" sz="2400" dirty="0">
+              <a:defRPr lang="en-US" sz="2600" dirty="0">
                 <a:solidFill>
                   <a:srgbClr val="6B7280"/>
                 </a:solidFill>
@@ -1295,7 +1295,7 @@
             <a:pPr algn="l" indent="0" marL="0">
               <a:buNone/>
             </a:pPr>
-            <a:endParaRPr lang="en-US" sz="2400" dirty="0"/>
+            <a:endParaRPr lang="en-US" sz="2600" dirty="0"/>
           </a:p>
         </p:txBody>
       </p:sp>
@@ -1943,28 +1943,28 @@
               <a:buNone/>
             </a:pPr>
             <a:r>
-              <a:rPr lang="en-US" sz="2400" dirty="0">
+              <a:rPr lang="en-US" sz="2600" dirty="0">
                 <a:solidFill>
                   <a:srgbClr val="6B7280"/>
                 </a:solidFill>
               </a:rPr>
               <a:t>Ask. Approve. Granted, for real, and on the record.</a:t>
             </a:r>
-            <a:endParaRPr lang="en-US" sz="2400" dirty="0"/>
+            <a:endParaRPr lang="en-US" sz="2600" dirty="0"/>
           </a:p>
           <a:p>
             <a:pPr algn="l" indent="0" marL="0">
               <a:buNone/>
             </a:pPr>
             <a:r>
-              <a:rPr lang="en-US" sz="2400" dirty="0">
+              <a:rPr lang="en-US" sz="2600" dirty="0">
                 <a:solidFill>
                   <a:srgbClr val="6B7280"/>
                 </a:solidFill>
               </a:rPr>
               <a:t>A governed front door for market data on a trading desk.</a:t>
             </a:r>
-            <a:endParaRPr lang="en-US" sz="2400" dirty="0"/>
+            <a:endParaRPr lang="en-US" sz="2600" dirty="0"/>
           </a:p>
         </p:txBody>
       </p:sp>
@@ -2119,14 +2119,14 @@
               <a:buNone/>
             </a:pPr>
             <a:r>
-              <a:rPr lang="en-US" sz="1800" b="1" dirty="0">
+              <a:rPr lang="en-US" sz="2000" b="1" dirty="0">
                 <a:solidFill>
                   <a:srgbClr val="C0392B"/>
                 </a:solidFill>
               </a:rPr>
               <a:t>Before: a ticket and an email chain</a:t>
             </a:r>
-            <a:endParaRPr lang="en-US" sz="1800" dirty="0"/>
+            <a:endParaRPr lang="en-US" sz="2000" dirty="0"/>
           </a:p>
         </p:txBody>
       </p:sp>
@@ -2156,14 +2156,14 @@
               <a:buChar char="•"/>
             </a:pPr>
             <a:r>
-              <a:rPr lang="en-US" sz="1500" dirty="0">
+              <a:rPr lang="en-US" sz="1700" dirty="0">
                 <a:solidFill>
                   <a:srgbClr val="141A22"/>
                 </a:solidFill>
               </a:rPr>
               <a:t>The analyst emails the owner and waits</a:t>
             </a:r>
-            <a:endParaRPr lang="en-US" sz="1500" dirty="0"/>
+            <a:endParaRPr lang="en-US" sz="1700" dirty="0"/>
           </a:p>
           <a:p>
             <a:pPr marL="342900" indent="-342900">
@@ -2171,14 +2171,14 @@
               <a:buChar char="•"/>
             </a:pPr>
             <a:r>
-              <a:rPr lang="en-US" sz="1500" dirty="0">
+              <a:rPr lang="en-US" sz="1700" dirty="0">
                 <a:solidFill>
                   <a:srgbClr val="141A22"/>
                 </a:solidFill>
               </a:rPr>
               <a:t>Nobody can say who has what, why, or what it costs</a:t>
             </a:r>
-            <a:endParaRPr lang="en-US" sz="1500" dirty="0"/>
+            <a:endParaRPr lang="en-US" sz="1700" dirty="0"/>
           </a:p>
           <a:p>
             <a:pPr marL="342900" indent="-342900">
@@ -2186,14 +2186,14 @@
               <a:buChar char="•"/>
             </a:pPr>
             <a:r>
-              <a:rPr lang="en-US" sz="1500" dirty="0">
+              <a:rPr lang="en-US" sz="1700" dirty="0">
                 <a:solidFill>
                   <a:srgbClr val="141A22"/>
                 </a:solidFill>
               </a:rPr>
               <a:t>Confidential tables get opened by habit</a:t>
             </a:r>
-            <a:endParaRPr lang="en-US" sz="1500" dirty="0"/>
+            <a:endParaRPr lang="en-US" sz="1700" dirty="0"/>
           </a:p>
         </p:txBody>
       </p:sp>
@@ -2249,14 +2249,14 @@
               <a:buNone/>
             </a:pPr>
             <a:r>
-              <a:rPr lang="en-US" sz="1800" b="1" dirty="0">
+              <a:rPr lang="en-US" sz="2000" b="1" dirty="0">
                 <a:solidFill>
                   <a:srgbClr val="1B8A4C"/>
                 </a:solidFill>
               </a:rPr>
               <a:t>After: Doorman</a:t>
             </a:r>
-            <a:endParaRPr lang="en-US" sz="1800" dirty="0"/>
+            <a:endParaRPr lang="en-US" sz="2000" dirty="0"/>
           </a:p>
         </p:txBody>
       </p:sp>
@@ -2286,14 +2286,14 @@
               <a:buChar char="•"/>
             </a:pPr>
             <a:r>
-              <a:rPr lang="en-US" sz="1500" dirty="0">
+              <a:rPr lang="en-US" sz="1700" dirty="0">
                 <a:solidFill>
                   <a:srgbClr val="141A22"/>
                 </a:solidFill>
               </a:rPr>
               <a:t>The analyst asks in the app, with a reason</a:t>
             </a:r>
-            <a:endParaRPr lang="en-US" sz="1500" dirty="0"/>
+            <a:endParaRPr lang="en-US" sz="1700" dirty="0"/>
           </a:p>
           <a:p>
             <a:pPr marL="342900" indent="-342900">
@@ -2301,14 +2301,14 @@
               <a:buChar char="•"/>
             </a:pPr>
             <a:r>
-              <a:rPr lang="en-US" sz="1500" dirty="0">
+              <a:rPr lang="en-US" sz="1700" dirty="0">
                 <a:solidFill>
                   <a:srgbClr val="141A22"/>
                 </a:solidFill>
               </a:rPr>
               <a:t>The owner sees the reason and the £ per month, then decides</a:t>
             </a:r>
-            <a:endParaRPr lang="en-US" sz="1500" dirty="0"/>
+            <a:endParaRPr lang="en-US" sz="1700" dirty="0"/>
           </a:p>
           <a:p>
             <a:pPr marL="342900" indent="-342900">
@@ -2316,14 +2316,14 @@
               <a:buChar char="•"/>
             </a:pPr>
             <a:r>
-              <a:rPr lang="en-US" sz="1500" dirty="0">
+              <a:rPr lang="en-US" sz="1700" dirty="0">
                 <a:solidFill>
                   <a:srgbClr val="141A22"/>
                 </a:solidFill>
               </a:rPr>
               <a:t>Approval is a real Unity Catalog grant; every step is on the record</a:t>
             </a:r>
-            <a:endParaRPr lang="en-US" sz="1500" dirty="0"/>
+            <a:endParaRPr lang="en-US" sz="1700" dirty="0"/>
           </a:p>
         </p:txBody>
       </p:sp>
@@ -2335,8 +2335,8 @@
         </p:nvSpPr>
         <p:spPr>
           <a:xfrm>
-            <a:off x="822960" y="5074920"/>
-            <a:ext cx="1463040" cy="731520"/>
+            <a:off x="822960" y="4709160"/>
+            <a:ext cx="3383280" cy="685800"/>
           </a:xfrm>
           <a:prstGeom prst="rect">
             <a:avLst/>
@@ -2371,8 +2371,8 @@
         </p:nvSpPr>
         <p:spPr>
           <a:xfrm>
-            <a:off x="2331720" y="5120640"/>
-            <a:ext cx="2011680" cy="731520"/>
+            <a:off x="822960" y="5394960"/>
+            <a:ext cx="3291840" cy="777240"/>
           </a:xfrm>
           <a:prstGeom prst="rect">
             <a:avLst/>
@@ -2388,28 +2388,14 @@
               <a:buNone/>
             </a:pPr>
             <a:r>
-              <a:rPr lang="en-US" sz="1200" dirty="0">
+              <a:rPr lang="en-US" sz="1500" dirty="0">
                 <a:solidFill>
                   <a:srgbClr val="6B7280"/>
                 </a:solidFill>
               </a:rPr>
-              <a:t>table is the queue</a:t>
-            </a:r>
-            <a:endParaRPr lang="en-US" sz="1200" dirty="0"/>
-          </a:p>
-          <a:p>
-            <a:pPr indent="0" marL="0">
-              <a:buNone/>
-            </a:pPr>
-            <a:r>
-              <a:rPr lang="en-US" sz="1200" dirty="0">
-                <a:solidFill>
-                  <a:srgbClr val="6B7280"/>
-                </a:solidFill>
-              </a:rPr>
-              <a:t>and the audit trail</a:t>
-            </a:r>
-            <a:endParaRPr lang="en-US" sz="1200" dirty="0"/>
+              <a:t>table holds both the approval queue and the audit trail</a:t>
+            </a:r>
+            <a:endParaRPr lang="en-US" sz="1500" dirty="0"/>
           </a:p>
         </p:txBody>
       </p:sp>
@@ -2421,8 +2407,8 @@
         </p:nvSpPr>
         <p:spPr>
           <a:xfrm>
-            <a:off x="4434840" y="5074920"/>
-            <a:ext cx="1463040" cy="731520"/>
+            <a:off x="4434840" y="4709160"/>
+            <a:ext cx="3383280" cy="685800"/>
           </a:xfrm>
           <a:prstGeom prst="rect">
             <a:avLst/>
@@ -2457,8 +2443,8 @@
         </p:nvSpPr>
         <p:spPr>
           <a:xfrm>
-            <a:off x="5943600" y="5120640"/>
-            <a:ext cx="2011680" cy="731520"/>
+            <a:off x="4434840" y="5394960"/>
+            <a:ext cx="3291840" cy="777240"/>
           </a:xfrm>
           <a:prstGeom prst="rect">
             <a:avLst/>
@@ -2474,28 +2460,14 @@
               <a:buNone/>
             </a:pPr>
             <a:r>
-              <a:rPr lang="en-US" sz="1200" dirty="0">
+              <a:rPr lang="en-US" sz="1500" dirty="0">
                 <a:solidFill>
                   <a:srgbClr val="6B7280"/>
                 </a:solidFill>
               </a:rPr>
-              <a:t>table names in code:</a:t>
-            </a:r>
-            <a:endParaRPr lang="en-US" sz="1200" dirty="0"/>
-          </a:p>
-          <a:p>
-            <a:pPr indent="0" marL="0">
-              <a:buNone/>
-            </a:pPr>
-            <a:r>
-              <a:rPr lang="en-US" sz="1200" dirty="0">
-                <a:solidFill>
-                  <a:srgbClr val="6B7280"/>
-                </a:solidFill>
-              </a:rPr>
-              <a:t>the catalogue is the tags</a:t>
-            </a:r>
-            <a:endParaRPr lang="en-US" sz="1200" dirty="0"/>
+              <a:t>table names hard-coded: the catalogue is built from Unity Catalog tags</a:t>
+            </a:r>
+            <a:endParaRPr lang="en-US" sz="1500" dirty="0"/>
           </a:p>
         </p:txBody>
       </p:sp>
@@ -2507,8 +2479,8 @@
         </p:nvSpPr>
         <p:spPr>
           <a:xfrm>
-            <a:off x="8046720" y="5074920"/>
-            <a:ext cx="1463040" cy="731520"/>
+            <a:off x="8046720" y="4709160"/>
+            <a:ext cx="3383280" cy="685800"/>
           </a:xfrm>
           <a:prstGeom prst="rect">
             <a:avLst/>
@@ -2543,8 +2515,8 @@
         </p:nvSpPr>
         <p:spPr>
           <a:xfrm>
-            <a:off x="9555480" y="5120640"/>
-            <a:ext cx="2011680" cy="731520"/>
+            <a:off x="8046720" y="5394960"/>
+            <a:ext cx="3291840" cy="777240"/>
           </a:xfrm>
           <a:prstGeom prst="rect">
             <a:avLst/>
@@ -2560,28 +2532,14 @@
               <a:buNone/>
             </a:pPr>
             <a:r>
-              <a:rPr lang="en-US" sz="1200" dirty="0">
+              <a:rPr lang="en-US" sz="1500" dirty="0">
                 <a:solidFill>
                   <a:srgbClr val="6B7280"/>
                 </a:solidFill>
               </a:rPr>
-              <a:t>per user per month for</a:t>
-            </a:r>
-            <a:endParaRPr lang="en-US" sz="1200" dirty="0"/>
-          </a:p>
-          <a:p>
-            <a:pPr indent="0" marL="0">
-              <a:buNone/>
-            </a:pPr>
-            <a:r>
-              <a:rPr lang="en-US" sz="1200" dirty="0">
-                <a:solidFill>
-                  <a:srgbClr val="6B7280"/>
-                </a:solidFill>
-              </a:rPr>
-              <a:t>one licensed price feed</a:t>
-            </a:r>
-            <a:endParaRPr lang="en-US" sz="1200" dirty="0"/>
+              <a:t>per user per month for one price feed: every approval is a spend decision</a:t>
+            </a:r>
+            <a:endParaRPr lang="en-US" sz="1500" dirty="0"/>
           </a:p>
         </p:txBody>
       </p:sp>
@@ -2828,14 +2786,14 @@
               <a:buNone/>
             </a:pPr>
             <a:r>
-              <a:rPr lang="en-US" sz="1500" b="1" dirty="0">
+              <a:rPr lang="en-US" sz="1700" b="1" dirty="0">
                 <a:solidFill>
                   <a:srgbClr val="141A22"/>
                 </a:solidFill>
               </a:rPr>
               <a:t>Owner, sensitivity, £ per month</a:t>
             </a:r>
-            <a:endParaRPr lang="en-US" sz="1500" dirty="0"/>
+            <a:endParaRPr lang="en-US" sz="1700" dirty="0"/>
           </a:p>
         </p:txBody>
       </p:sp>
@@ -2848,7 +2806,7 @@
         <p:spPr>
           <a:xfrm>
             <a:off x="1280160" y="5440346"/>
-            <a:ext cx="2926080" cy="822960"/>
+            <a:ext cx="2926080" cy="868680"/>
           </a:xfrm>
           <a:prstGeom prst="rect">
             <a:avLst/>
@@ -2864,14 +2822,14 @@
               <a:buNone/>
             </a:pPr>
             <a:r>
-              <a:rPr lang="en-US" sz="1300" dirty="0">
+              <a:rPr lang="en-US" sz="1500" dirty="0">
                 <a:solidFill>
                   <a:srgbClr val="6B7280"/>
                 </a:solidFill>
               </a:rPr>
               <a:t>All three are Unity Catalog tags on the table. Tag a new table and it appears here. No deploy.</a:t>
             </a:r>
-            <a:endParaRPr lang="en-US" sz="1300" dirty="0"/>
+            <a:endParaRPr lang="en-US" sz="1500" dirty="0"/>
           </a:p>
         </p:txBody>
       </p:sp>
@@ -2961,14 +2919,14 @@
               <a:buNone/>
             </a:pPr>
             <a:r>
-              <a:rPr lang="en-US" sz="1500" b="1" dirty="0">
+              <a:rPr lang="en-US" sz="1700" b="1" dirty="0">
                 <a:solidFill>
                   <a:srgbClr val="141A22"/>
                 </a:solidFill>
               </a:rPr>
-              <a:t>Two owners, three products each</a:t>
-            </a:r>
-            <a:endParaRPr lang="en-US" sz="1500" dirty="0"/>
+              <a:t>Two owners, three each</a:t>
+            </a:r>
+            <a:endParaRPr lang="en-US" sz="1700" dirty="0"/>
           </a:p>
         </p:txBody>
       </p:sp>
@@ -2981,7 +2939,7 @@
         <p:spPr>
           <a:xfrm>
             <a:off x="4846320" y="5440346"/>
-            <a:ext cx="2926080" cy="822960"/>
+            <a:ext cx="2926080" cy="868680"/>
           </a:xfrm>
           <a:prstGeom prst="rect">
             <a:avLst/>
@@ -2997,14 +2955,14 @@
               <a:buNone/>
             </a:pPr>
             <a:r>
-              <a:rPr lang="en-US" sz="1300" dirty="0">
+              <a:rPr lang="en-US" sz="1500" dirty="0">
                 <a:solidFill>
                   <a:srgbClr val="6B7280"/>
                 </a:solidFill>
               </a:rPr>
               <a:t>Price data routes to Younis, corporate actions and the trading book to Jose. The tag decides.</a:t>
             </a:r>
-            <a:endParaRPr lang="en-US" sz="1300" dirty="0"/>
+            <a:endParaRPr lang="en-US" sz="1500" dirty="0"/>
           </a:p>
         </p:txBody>
       </p:sp>
@@ -3094,14 +3052,14 @@
               <a:buNone/>
             </a:pPr>
             <a:r>
-              <a:rPr lang="en-US" sz="1500" b="1" dirty="0">
+              <a:rPr lang="en-US" sz="1700" b="1" dirty="0">
                 <a:solidFill>
                   <a:srgbClr val="141A22"/>
                 </a:solidFill>
               </a:rPr>
               <a:t>Your access, live</a:t>
             </a:r>
-            <a:endParaRPr lang="en-US" sz="1500" dirty="0"/>
+            <a:endParaRPr lang="en-US" sz="1700" dirty="0"/>
           </a:p>
         </p:txBody>
       </p:sp>
@@ -3114,7 +3072,7 @@
         <p:spPr>
           <a:xfrm>
             <a:off x="8412480" y="5440346"/>
-            <a:ext cx="2926080" cy="822960"/>
+            <a:ext cx="2926080" cy="868680"/>
           </a:xfrm>
           <a:prstGeom prst="rect">
             <a:avLst/>
@@ -3130,14 +3088,14 @@
               <a:buNone/>
             </a:pPr>
             <a:r>
-              <a:rPr lang="en-US" sz="1300" dirty="0">
+              <a:rPr lang="en-US" sz="1500" dirty="0">
                 <a:solidFill>
                   <a:srgbClr val="6B7280"/>
                 </a:solidFill>
               </a:rPr>
               <a:t>Granted, pending, rejected or none, from the request log. Once granted: query it, or download a CSV.</a:t>
             </a:r>
-            <a:endParaRPr lang="en-US" sz="1300" dirty="0"/>
+            <a:endParaRPr lang="en-US" sz="1500" dirty="0"/>
           </a:p>
         </p:txBody>
       </p:sp>
@@ -3384,14 +3342,14 @@
               <a:buNone/>
             </a:pPr>
             <a:r>
-              <a:rPr lang="en-US" sz="1500" b="1" dirty="0">
+              <a:rPr lang="en-US" sz="1700" b="1" dirty="0">
                 <a:solidFill>
                   <a:srgbClr val="141A22"/>
                 </a:solidFill>
               </a:rPr>
               <a:t>The price is the hero</a:t>
             </a:r>
-            <a:endParaRPr lang="en-US" sz="1500" dirty="0"/>
+            <a:endParaRPr lang="en-US" sz="1700" dirty="0"/>
           </a:p>
         </p:txBody>
       </p:sp>
@@ -3404,7 +3362,7 @@
         <p:spPr>
           <a:xfrm>
             <a:off x="8452714" y="1920240"/>
-            <a:ext cx="2885846" cy="822960"/>
+            <a:ext cx="2885846" cy="868680"/>
           </a:xfrm>
           <a:prstGeom prst="rect">
             <a:avLst/>
@@ -3420,14 +3378,14 @@
               <a:buNone/>
             </a:pPr>
             <a:r>
-              <a:rPr lang="en-US" sz="1300" dirty="0">
+              <a:rPr lang="en-US" sz="1500" dirty="0">
                 <a:solidFill>
                   <a:srgbClr val="6B7280"/>
                 </a:solidFill>
               </a:rPr>
               <a:t>£120 per user per month, read from the licence_cost_gbp tag. Every yes is a spend decision.</a:t>
             </a:r>
-            <a:endParaRPr lang="en-US" sz="1300" dirty="0"/>
+            <a:endParaRPr lang="en-US" sz="1500" dirty="0"/>
           </a:p>
         </p:txBody>
       </p:sp>
@@ -3517,14 +3475,14 @@
               <a:buNone/>
             </a:pPr>
             <a:r>
-              <a:rPr lang="en-US" sz="1500" b="1" dirty="0">
+              <a:rPr lang="en-US" sz="1700" b="1" dirty="0">
                 <a:solidFill>
                   <a:srgbClr val="141A22"/>
                 </a:solidFill>
               </a:rPr>
               <a:t>A reason is required</a:t>
             </a:r>
-            <a:endParaRPr lang="en-US" sz="1500" dirty="0"/>
+            <a:endParaRPr lang="en-US" sz="1700" dirty="0"/>
           </a:p>
         </p:txBody>
       </p:sp>
@@ -3537,7 +3495,7 @@
         <p:spPr>
           <a:xfrm>
             <a:off x="8452714" y="3108960"/>
-            <a:ext cx="2885846" cy="822960"/>
+            <a:ext cx="2885846" cy="868680"/>
           </a:xfrm>
           <a:prstGeom prst="rect">
             <a:avLst/>
@@ -3553,14 +3511,14 @@
               <a:buNone/>
             </a:pPr>
             <a:r>
-              <a:rPr lang="en-US" sz="1300" dirty="0">
+              <a:rPr lang="en-US" sz="1500" dirty="0">
                 <a:solidFill>
                   <a:srgbClr val="6B7280"/>
                 </a:solidFill>
               </a:rPr>
               <a:t>The owner reads it before deciding. An AI classifier flags vague reasons so the owner sees that too.</a:t>
             </a:r>
-            <a:endParaRPr lang="en-US" sz="1300" dirty="0"/>
+            <a:endParaRPr lang="en-US" sz="1500" dirty="0"/>
           </a:p>
         </p:txBody>
       </p:sp>
@@ -3650,14 +3608,14 @@
               <a:buNone/>
             </a:pPr>
             <a:r>
-              <a:rPr lang="en-US" sz="1500" b="1" dirty="0">
+              <a:rPr lang="en-US" sz="1700" b="1" dirty="0">
                 <a:solidFill>
                   <a:srgbClr val="141A22"/>
                 </a:solidFill>
               </a:rPr>
               <a:t>Where it is</a:t>
             </a:r>
-            <a:endParaRPr lang="en-US" sz="1500" dirty="0"/>
+            <a:endParaRPr lang="en-US" sz="1700" dirty="0"/>
           </a:p>
         </p:txBody>
       </p:sp>
@@ -3670,7 +3628,7 @@
         <p:spPr>
           <a:xfrm>
             <a:off x="8452714" y="4297680"/>
-            <a:ext cx="2885846" cy="822960"/>
+            <a:ext cx="2885846" cy="868680"/>
           </a:xfrm>
           <a:prstGeom prst="rect">
             <a:avLst/>
@@ -3686,14 +3644,14 @@
               <a:buNone/>
             </a:pPr>
             <a:r>
-              <a:rPr lang="en-US" sz="1300" dirty="0">
+              <a:rPr lang="en-US" sz="1500" dirty="0">
                 <a:solidFill>
                   <a:srgbClr val="6B7280"/>
                 </a:solidFill>
               </a:rPr>
               <a:t>Request, owner review, access granted: the tracker fills as the owner acts.</a:t>
             </a:r>
-            <a:endParaRPr lang="en-US" sz="1300" dirty="0"/>
+            <a:endParaRPr lang="en-US" sz="1500" dirty="0"/>
           </a:p>
         </p:txBody>
       </p:sp>
@@ -3783,14 +3741,14 @@
               <a:buNone/>
             </a:pPr>
             <a:r>
-              <a:rPr lang="en-US" sz="1500" b="1" dirty="0">
+              <a:rPr lang="en-US" sz="1700" b="1" dirty="0">
                 <a:solidFill>
                   <a:srgbClr val="141A22"/>
                 </a:solidFill>
               </a:rPr>
               <a:t>Nothing hard-coded</a:t>
             </a:r>
-            <a:endParaRPr lang="en-US" sz="1500" dirty="0"/>
+            <a:endParaRPr lang="en-US" sz="1700" dirty="0"/>
           </a:p>
         </p:txBody>
       </p:sp>
@@ -3803,7 +3761,7 @@
         <p:spPr>
           <a:xfrm>
             <a:off x="8452714" y="5486400"/>
-            <a:ext cx="2885846" cy="822960"/>
+            <a:ext cx="2885846" cy="868680"/>
           </a:xfrm>
           <a:prstGeom prst="rect">
             <a:avLst/>
@@ -3819,14 +3777,14 @@
               <a:buNone/>
             </a:pPr>
             <a:r>
-              <a:rPr lang="en-US" sz="1300" dirty="0">
+              <a:rPr lang="en-US" sz="1500" dirty="0">
                 <a:solidFill>
                   <a:srgbClr val="6B7280"/>
                 </a:solidFill>
               </a:rPr>
               <a:t>Owner, cost, sensitivity and the table itself come from Unity Catalog. The app only reads.</a:t>
             </a:r>
-            <a:endParaRPr lang="en-US" sz="1300" dirty="0"/>
+            <a:endParaRPr lang="en-US" sz="1500" dirty="0"/>
           </a:p>
         </p:txBody>
       </p:sp>
@@ -4026,14 +3984,14 @@
               <a:buNone/>
             </a:pPr>
             <a:r>
-              <a:rPr lang="en-US" sz="1600" b="1" dirty="0">
+              <a:rPr lang="en-US" sz="1800" b="1" dirty="0">
                 <a:solidFill>
                   <a:srgbClr val="141A22"/>
                 </a:solidFill>
               </a:rPr>
               <a:t>Analyst asks</a:t>
             </a:r>
-            <a:endParaRPr lang="en-US" sz="1600" dirty="0"/>
+            <a:endParaRPr lang="en-US" sz="1800" dirty="0"/>
           </a:p>
         </p:txBody>
       </p:sp>
@@ -4062,14 +4020,14 @@
               <a:buNone/>
             </a:pPr>
             <a:r>
-              <a:rPr lang="en-US" sz="1200" dirty="0">
+              <a:rPr lang="en-US" sz="1400" dirty="0">
                 <a:solidFill>
                   <a:srgbClr val="6B7280"/>
                 </a:solidFill>
               </a:rPr>
               <a:t>Picks a table, gives a reason</a:t>
             </a:r>
-            <a:endParaRPr lang="en-US" sz="1200" dirty="0"/>
+            <a:endParaRPr lang="en-US" sz="1400" dirty="0"/>
           </a:p>
         </p:txBody>
       </p:sp>
@@ -4161,14 +4119,14 @@
               <a:buNone/>
             </a:pPr>
             <a:r>
-              <a:rPr lang="en-US" sz="1600" b="1" dirty="0">
+              <a:rPr lang="en-US" sz="1800" b="1" dirty="0">
                 <a:solidFill>
                   <a:srgbClr val="141A22"/>
                 </a:solidFill>
               </a:rPr>
               <a:t>Owner from the tag</a:t>
             </a:r>
-            <a:endParaRPr lang="en-US" sz="1600" dirty="0"/>
+            <a:endParaRPr lang="en-US" sz="1800" dirty="0"/>
           </a:p>
         </p:txBody>
       </p:sp>
@@ -4197,14 +4155,14 @@
               <a:buNone/>
             </a:pPr>
             <a:r>
-              <a:rPr lang="en-US" sz="1200" dirty="0">
+              <a:rPr lang="en-US" sz="1400" dirty="0">
                 <a:solidFill>
                   <a:srgbClr val="6B7280"/>
                 </a:solidFill>
               </a:rPr>
               <a:t>data_owner on the table, not a config file</a:t>
             </a:r>
-            <a:endParaRPr lang="en-US" sz="1200" dirty="0"/>
+            <a:endParaRPr lang="en-US" sz="1400" dirty="0"/>
           </a:p>
         </p:txBody>
       </p:sp>
@@ -4296,14 +4254,14 @@
               <a:buNone/>
             </a:pPr>
             <a:r>
-              <a:rPr lang="en-US" sz="1600" b="1" dirty="0">
+              <a:rPr lang="en-US" sz="1800" b="1" dirty="0">
                 <a:solidFill>
                   <a:srgbClr val="141A22"/>
                 </a:solidFill>
               </a:rPr>
               <a:t>Owner decides</a:t>
             </a:r>
-            <a:endParaRPr lang="en-US" sz="1600" dirty="0"/>
+            <a:endParaRPr lang="en-US" sz="1800" dirty="0"/>
           </a:p>
         </p:txBody>
       </p:sp>
@@ -4332,14 +4290,14 @@
               <a:buNone/>
             </a:pPr>
             <a:r>
-              <a:rPr lang="en-US" sz="1200" dirty="0">
+              <a:rPr lang="en-US" sz="1400" dirty="0">
                 <a:solidFill>
                   <a:srgbClr val="6B7280"/>
                 </a:solidFill>
               </a:rPr>
               <a:t>Sees the £, the reason, the sensitivity</a:t>
             </a:r>
-            <a:endParaRPr lang="en-US" sz="1200" dirty="0"/>
+            <a:endParaRPr lang="en-US" sz="1400" dirty="0"/>
           </a:p>
         </p:txBody>
       </p:sp>
@@ -4431,14 +4389,14 @@
               <a:buNone/>
             </a:pPr>
             <a:r>
-              <a:rPr lang="en-US" sz="1600" b="1" dirty="0">
+              <a:rPr lang="en-US" sz="1800" b="1" dirty="0">
                 <a:solidFill>
                   <a:srgbClr val="FFFFFF"/>
                 </a:solidFill>
               </a:rPr>
               <a:t>Real grant</a:t>
             </a:r>
-            <a:endParaRPr lang="en-US" sz="1600" dirty="0"/>
+            <a:endParaRPr lang="en-US" sz="1800" dirty="0"/>
           </a:p>
         </p:txBody>
       </p:sp>
@@ -4467,14 +4425,14 @@
               <a:buNone/>
             </a:pPr>
             <a:r>
-              <a:rPr lang="en-US" sz="1200" dirty="0">
+              <a:rPr lang="en-US" sz="1400" dirty="0">
                 <a:solidFill>
                   <a:srgbClr val="FFFFFF"/>
                 </a:solidFill>
               </a:rPr>
               <a:t>GRANT SELECT in Unity Catalog, or a reject with a note</a:t>
             </a:r>
-            <a:endParaRPr lang="en-US" sz="1200" dirty="0"/>
+            <a:endParaRPr lang="en-US" sz="1400" dirty="0"/>
           </a:p>
         </p:txBody>
       </p:sp>
@@ -4566,14 +4524,14 @@
               <a:buNone/>
             </a:pPr>
             <a:r>
-              <a:rPr lang="en-US" sz="1600" b="1" dirty="0">
+              <a:rPr lang="en-US" sz="1800" b="1" dirty="0">
                 <a:solidFill>
                   <a:srgbClr val="141A22"/>
                 </a:solidFill>
               </a:rPr>
               <a:t>Queue and receipt</a:t>
             </a:r>
-            <a:endParaRPr lang="en-US" sz="1600" dirty="0"/>
+            <a:endParaRPr lang="en-US" sz="1800" dirty="0"/>
           </a:p>
         </p:txBody>
       </p:sp>
@@ -4602,14 +4560,14 @@
               <a:buNone/>
             </a:pPr>
             <a:r>
-              <a:rPr lang="en-US" sz="1200" dirty="0">
+              <a:rPr lang="en-US" sz="1400" dirty="0">
                 <a:solidFill>
                   <a:srgbClr val="6B7280"/>
                 </a:solidFill>
               </a:rPr>
               <a:t>One table holds every step; Genie answers questions on it</a:t>
             </a:r>
-            <a:endParaRPr lang="en-US" sz="1200" dirty="0"/>
+            <a:endParaRPr lang="en-US" sz="1400" dirty="0"/>
           </a:p>
         </p:txBody>
       </p:sp>
@@ -4665,14 +4623,14 @@
               <a:buNone/>
             </a:pPr>
             <a:r>
-              <a:rPr lang="en-US" sz="1800" b="1" dirty="0">
+              <a:rPr lang="en-US" sz="2000" b="1" dirty="0">
                 <a:solidFill>
                   <a:srgbClr val="3451D1"/>
                 </a:solidFill>
               </a:rPr>
               <a:t>Runs as the signed-in user</a:t>
             </a:r>
-            <a:endParaRPr lang="en-US" sz="1800" dirty="0"/>
+            <a:endParaRPr lang="en-US" sz="2000" dirty="0"/>
           </a:p>
         </p:txBody>
       </p:sp>
@@ -4701,14 +4659,14 @@
               <a:buNone/>
             </a:pPr>
             <a:r>
-              <a:rPr lang="en-US" sz="1500" dirty="0">
+              <a:rPr lang="en-US" sz="1700" dirty="0">
                 <a:solidFill>
                   <a:srgbClr val="141A22"/>
                 </a:solidFill>
               </a:rPr>
               <a:t>The app forwards each user's own Databricks identity to the SQL warehouse. A person's rights in Doorman are exactly their rights in Unity Catalog; the app never flips a flag of its own. Denied before, rows after.</a:t>
             </a:r>
-            <a:endParaRPr lang="en-US" sz="1500" dirty="0"/>
+            <a:endParaRPr lang="en-US" sz="1700" dirty="0"/>
           </a:p>
         </p:txBody>
       </p:sp>
@@ -4829,11 +4787,11 @@
         <p:spPr>
           <a:xfrm>
             <a:off x="822960" y="1554480"/>
-            <a:ext cx="3383280" cy="2377440"/>
+            <a:ext cx="3383280" cy="2148840"/>
           </a:xfrm>
           <a:prstGeom prst="roundRect">
             <a:avLst>
-              <a:gd name="adj" fmla="val 5385"/>
+              <a:gd name="adj" fmla="val 5957"/>
             </a:avLst>
           </a:prstGeom>
           <a:solidFill>
@@ -4872,14 +4830,14 @@
               <a:buNone/>
             </a:pPr>
             <a:r>
-              <a:rPr lang="en-US" sz="1800" b="1" dirty="0">
+              <a:rPr lang="en-US" sz="2000" b="1" dirty="0">
                 <a:solidFill>
                   <a:srgbClr val="3451D1"/>
                 </a:solidFill>
               </a:rPr>
               <a:t>The catalogue is the tags</a:t>
             </a:r>
-            <a:endParaRPr lang="en-US" sz="1800" dirty="0"/>
+            <a:endParaRPr lang="en-US" sz="2000" dirty="0"/>
           </a:p>
         </p:txBody>
       </p:sp>
@@ -4892,7 +4850,7 @@
         <p:spPr>
           <a:xfrm>
             <a:off x="1097280" y="2560320"/>
-            <a:ext cx="2834640" cy="1188720"/>
+            <a:ext cx="2834640" cy="960120"/>
           </a:xfrm>
           <a:prstGeom prst="rect">
             <a:avLst/>
@@ -4908,14 +4866,14 @@
               <a:buNone/>
             </a:pPr>
             <a:r>
-              <a:rPr lang="en-US" sz="1500" dirty="0">
+              <a:rPr lang="en-US" sz="1700" dirty="0">
                 <a:solidFill>
                   <a:srgbClr val="141A22"/>
                 </a:solidFill>
               </a:rPr>
               <a:t>Requestable means: carries a data_owner tag. Reuse is one ALTER TABLE.</a:t>
             </a:r>
-            <a:endParaRPr lang="en-US" sz="1500" dirty="0"/>
+            <a:endParaRPr lang="en-US" sz="1700" dirty="0"/>
           </a:p>
         </p:txBody>
       </p:sp>
@@ -4928,11 +4886,11 @@
         <p:spPr>
           <a:xfrm>
             <a:off x="4389120" y="1554480"/>
-            <a:ext cx="3383280" cy="2377440"/>
+            <a:ext cx="3383280" cy="2148840"/>
           </a:xfrm>
           <a:prstGeom prst="roundRect">
             <a:avLst>
-              <a:gd name="adj" fmla="val 5385"/>
+              <a:gd name="adj" fmla="val 5957"/>
             </a:avLst>
           </a:prstGeom>
           <a:solidFill>
@@ -4971,14 +4929,14 @@
               <a:buNone/>
             </a:pPr>
             <a:r>
-              <a:rPr lang="en-US" sz="1800" b="1" dirty="0">
+              <a:rPr lang="en-US" sz="2000" b="1" dirty="0">
                 <a:solidFill>
                   <a:srgbClr val="3451D1"/>
                 </a:solidFill>
               </a:rPr>
               <a:t>Only the owner decides</a:t>
             </a:r>
-            <a:endParaRPr lang="en-US" sz="1800" dirty="0"/>
+            <a:endParaRPr lang="en-US" sz="2000" dirty="0"/>
           </a:p>
         </p:txBody>
       </p:sp>
@@ -4991,7 +4949,7 @@
         <p:spPr>
           <a:xfrm>
             <a:off x="4663440" y="2560320"/>
-            <a:ext cx="2834640" cy="1188720"/>
+            <a:ext cx="2834640" cy="960120"/>
           </a:xfrm>
           <a:prstGeom prst="rect">
             <a:avLst/>
@@ -5007,14 +4965,14 @@
               <a:buNone/>
             </a:pPr>
             <a:r>
-              <a:rPr lang="en-US" sz="1500" dirty="0">
+              <a:rPr lang="en-US" sz="1700" dirty="0">
                 <a:solidFill>
                   <a:srgbClr val="141A22"/>
                 </a:solidFill>
               </a:rPr>
               <a:t>The approver comes from the tag at request time. Anyone else is refused by code, not by UI.</a:t>
             </a:r>
-            <a:endParaRPr lang="en-US" sz="1500" dirty="0"/>
+            <a:endParaRPr lang="en-US" sz="1700" dirty="0"/>
           </a:p>
         </p:txBody>
       </p:sp>
@@ -5027,11 +4985,11 @@
         <p:spPr>
           <a:xfrm>
             <a:off x="7955280" y="1554480"/>
-            <a:ext cx="3383280" cy="2377440"/>
+            <a:ext cx="3383280" cy="2148840"/>
           </a:xfrm>
           <a:prstGeom prst="roundRect">
             <a:avLst>
-              <a:gd name="adj" fmla="val 5385"/>
+              <a:gd name="adj" fmla="val 5957"/>
             </a:avLst>
           </a:prstGeom>
           <a:solidFill>
@@ -5070,14 +5028,14 @@
               <a:buNone/>
             </a:pPr>
             <a:r>
-              <a:rPr lang="en-US" sz="1800" b="1" dirty="0">
+              <a:rPr lang="en-US" sz="2000" b="1" dirty="0">
                 <a:solidFill>
                   <a:srgbClr val="3451D1"/>
                 </a:solidFill>
               </a:rPr>
               <a:t>Nothing is hidden</a:t>
             </a:r>
-            <a:endParaRPr lang="en-US" sz="1800" dirty="0"/>
+            <a:endParaRPr lang="en-US" sz="2000" dirty="0"/>
           </a:p>
         </p:txBody>
       </p:sp>
@@ -5090,7 +5048,7 @@
         <p:spPr>
           <a:xfrm>
             <a:off x="8229600" y="2560320"/>
-            <a:ext cx="2834640" cy="1188720"/>
+            <a:ext cx="2834640" cy="960120"/>
           </a:xfrm>
           <a:prstGeom prst="rect">
             <a:avLst/>
@@ -5106,14 +5064,14 @@
               <a:buNone/>
             </a:pPr>
             <a:r>
-              <a:rPr lang="en-US" sz="1500" dirty="0">
+              <a:rPr lang="en-US" sz="1700" dirty="0">
                 <a:solidFill>
                   <a:srgbClr val="141A22"/>
                 </a:solidFill>
               </a:rPr>
               <a:t>Reject needs a note the requester sees. A failed grant is recorded with its error. Revoke keeps the record.</a:t>
             </a:r>
-            <a:endParaRPr lang="en-US" sz="1500" dirty="0"/>
+            <a:endParaRPr lang="en-US" sz="1700" dirty="0"/>
           </a:p>
         </p:txBody>
       </p:sp>
@@ -5125,12 +5083,12 @@
         </p:nvSpPr>
         <p:spPr>
           <a:xfrm>
-            <a:off x="822960" y="4206240"/>
-            <a:ext cx="10515600" cy="1920240"/>
+            <a:off x="822960" y="3886200"/>
+            <a:ext cx="10515600" cy="2286000"/>
           </a:xfrm>
           <a:prstGeom prst="roundRect">
             <a:avLst>
-              <a:gd name="adj" fmla="val 6667"/>
+              <a:gd name="adj" fmla="val 5600"/>
             </a:avLst>
           </a:prstGeom>
           <a:solidFill>
@@ -5152,7 +5110,7 @@
         </p:nvSpPr>
         <p:spPr>
           <a:xfrm>
-            <a:off x="1097280" y="4434840"/>
+            <a:off x="1097280" y="4114800"/>
             <a:ext cx="9966960" cy="731520"/>
           </a:xfrm>
           <a:prstGeom prst="rect">
@@ -5169,14 +5127,14 @@
               <a:buNone/>
             </a:pPr>
             <a:r>
-              <a:rPr lang="en-US" sz="1800" b="1" dirty="0">
+              <a:rPr lang="en-US" sz="2000" b="1" dirty="0">
                 <a:solidFill>
                   <a:srgbClr val="1B8A4C"/>
                 </a:solidFill>
               </a:rPr>
               <a:t>Proof it is real, shown live</a:t>
             </a:r>
-            <a:endParaRPr lang="en-US" sz="1800" dirty="0"/>
+            <a:endParaRPr lang="en-US" sz="2000" dirty="0"/>
           </a:p>
         </p:txBody>
       </p:sp>
@@ -5188,8 +5146,8 @@
         </p:nvSpPr>
         <p:spPr>
           <a:xfrm>
-            <a:off x="1097280" y="5212080"/>
-            <a:ext cx="9966960" cy="731520"/>
+            <a:off x="1097280" y="4892040"/>
+            <a:ext cx="9966960" cy="1097280"/>
           </a:xfrm>
           <a:prstGeom prst="rect">
             <a:avLst/>
@@ -5206,14 +5164,14 @@
               <a:buChar char="•"/>
             </a:pPr>
             <a:r>
-              <a:rPr lang="en-US" sz="1500" dirty="0">
+              <a:rPr lang="en-US" sz="1700" dirty="0">
                 <a:solidFill>
                   <a:srgbClr val="141A22"/>
                 </a:solidFill>
               </a:rPr>
-              <a:t>SHOW GRANTS on the table lists the requester after approval and not before; the same query fails, then returns rows</a:t>
-            </a:r>
-            <a:endParaRPr lang="en-US" sz="1500" dirty="0"/>
+              <a:t>SHOW GRANTS lists the requester after approval, not before; the same query fails, then returns rows</a:t>
+            </a:r>
+            <a:endParaRPr lang="en-US" sz="1700" dirty="0"/>
           </a:p>
           <a:p>
             <a:pPr marL="342900" indent="-342900">
@@ -5221,14 +5179,14 @@
               <a:buChar char="•"/>
             </a:pPr>
             <a:r>
-              <a:rPr lang="en-US" sz="1500" dirty="0">
+              <a:rPr lang="en-US" sz="1700" dirty="0">
                 <a:solidFill>
                   <a:srgbClr val="141A22"/>
                 </a:solidFill>
               </a:rPr>
-              <a:t>A teammate tagged a new table mid-evening and it appeared in the catalogue with no deploy</a:t>
-            </a:r>
-            <a:endParaRPr lang="en-US" sz="1500" dirty="0"/>
+              <a:t>A teammate tagged a new table mid-evening; it appeared with no deploy</a:t>
+            </a:r>
+            <a:endParaRPr lang="en-US" sz="1700" dirty="0"/>
           </a:p>
           <a:p>
             <a:pPr marL="342900" indent="-342900">
@@ -5236,14 +5194,14 @@
               <a:buChar char="•"/>
             </a:pPr>
             <a:r>
-              <a:rPr lang="en-US" sz="1500" dirty="0">
+              <a:rPr lang="en-US" sz="1700" dirty="0">
                 <a:solidFill>
                   <a:srgbClr val="141A22"/>
                 </a:solidFill>
               </a:rPr>
-              <a:t>Genie answers "what is our licence spend by table?" from the audit table alone; 39 automated tests; only governance.py can grant</a:t>
-            </a:r>
-            <a:endParaRPr lang="en-US" sz="1500" dirty="0"/>
+              <a:t>Genie answers spend questions from the audit table alone; 39 tests; only governance.py can grant</a:t>
+            </a:r>
+            <a:endParaRPr lang="en-US" sz="1700" dirty="0"/>
           </a:p>
         </p:txBody>
       </p:sp>
@@ -5382,7 +5340,7 @@
                 <a:gridCol w="5577840"/>
                 <a:gridCol w="1097280"/>
               </a:tblGrid>
-              <a:tr h="475488">
+              <a:tr h="457200">
                 <a:tc>
                   <a:txBody>
                     <a:bodyPr/>
@@ -5392,7 +5350,7 @@
                         <a:buNone/>
                       </a:pPr>
                       <a:r>
-                        <a:rPr lang="en-US" sz="1200" b="1" dirty="0">
+                        <a:rPr lang="en-US" sz="1300" b="1" dirty="0">
                           <a:solidFill>
                             <a:srgbClr val="6B7280"/>
                           </a:solidFill>
@@ -5402,7 +5360,7 @@
                         </a:rPr>
                         <a:t>Colibri asked for</a:t>
                       </a:r>
-                      <a:endParaRPr lang="en-US" sz="1200" dirty="0">
+                      <a:endParaRPr lang="en-US" sz="1300" dirty="0">
                         <a:latin typeface="+mn-lt" charset="0"/>
                         <a:ea typeface="+mn-lt" charset="0"/>
                         <a:cs typeface="+mn-lt" charset="0"/>
@@ -5460,7 +5418,7 @@
                         <a:buNone/>
                       </a:pPr>
                       <a:r>
-                        <a:rPr lang="en-US" sz="1200" b="1" dirty="0">
+                        <a:rPr lang="en-US" sz="1300" b="1" dirty="0">
                           <a:solidFill>
                             <a:srgbClr val="6B7280"/>
                           </a:solidFill>
@@ -5470,7 +5428,7 @@
                         </a:rPr>
                         <a:t>Doorman</a:t>
                       </a:r>
-                      <a:endParaRPr lang="en-US" sz="1200" dirty="0">
+                      <a:endParaRPr lang="en-US" sz="1300" dirty="0">
                         <a:latin typeface="+mn-lt" charset="0"/>
                         <a:ea typeface="+mn-lt" charset="0"/>
                         <a:cs typeface="+mn-lt" charset="0"/>
@@ -5527,7 +5485,7 @@
                       <a:pPr indent="0" marL="0">
                         <a:buNone/>
                       </a:pPr>
-                      <a:endParaRPr lang="en-US" sz="1200" dirty="0">
+                      <a:endParaRPr lang="en-US" sz="1300" dirty="0">
                         <a:latin typeface="+mn-lt" charset="0"/>
                         <a:ea typeface="+mn-lt" charset="0"/>
                         <a:cs typeface="+mn-lt" charset="0"/>
@@ -5577,7 +5535,7 @@
                   </a:tcPr>
                 </a:tc>
               </a:tr>
-              <a:tr h="475488">
+              <a:tr h="457200">
                 <a:tc>
                   <a:txBody>
                     <a:bodyPr/>
@@ -5587,7 +5545,7 @@
                         <a:buNone/>
                       </a:pPr>
                       <a:r>
-                        <a:rPr lang="en-US" sz="1250" dirty="0">
+                        <a:rPr lang="en-US" sz="1300" dirty="0">
                           <a:solidFill>
                             <a:srgbClr val="141A22"/>
                           </a:solidFill>
@@ -5597,7 +5555,7 @@
                         </a:rPr>
                         <a:t>Request in the app: pick a Unity Catalog asset, give a reason</a:t>
                       </a:r>
-                      <a:endParaRPr lang="en-US" sz="1250" dirty="0">
+                      <a:endParaRPr lang="en-US" sz="1300" dirty="0">
                         <a:latin typeface="+mn-lt" charset="0"/>
                         <a:ea typeface="+mn-lt" charset="0"/>
                         <a:cs typeface="+mn-lt" charset="0"/>
@@ -5655,7 +5613,7 @@
                         <a:buNone/>
                       </a:pPr>
                       <a:r>
-                        <a:rPr lang="en-US" sz="1250" dirty="0">
+                        <a:rPr lang="en-US" sz="1300" dirty="0">
                           <a:solidFill>
                             <a:srgbClr val="141A22"/>
                           </a:solidFill>
@@ -5665,7 +5623,7 @@
                         </a:rPr>
                         <a:t>Catalogue page lists every tagged table; a reason is required and AI-flagged if vague</a:t>
                       </a:r>
-                      <a:endParaRPr lang="en-US" sz="1250" dirty="0">
+                      <a:endParaRPr lang="en-US" sz="1300" dirty="0">
                         <a:latin typeface="+mn-lt" charset="0"/>
                         <a:ea typeface="+mn-lt" charset="0"/>
                         <a:cs typeface="+mn-lt" charset="0"/>
@@ -5723,7 +5681,7 @@
                         <a:buNone/>
                       </a:pPr>
                       <a:r>
-                        <a:rPr lang="en-US" sz="1250" b="1" dirty="0">
+                        <a:rPr lang="en-US" sz="1300" b="1" dirty="0">
                           <a:solidFill>
                             <a:srgbClr val="1B8A4C"/>
                           </a:solidFill>
@@ -5733,7 +5691,7 @@
                         </a:rPr>
                         <a:t>Done</a:t>
                       </a:r>
-                      <a:endParaRPr lang="en-US" sz="1250" dirty="0">
+                      <a:endParaRPr lang="en-US" sz="1300" dirty="0">
                         <a:latin typeface="+mn-lt" charset="0"/>
                         <a:ea typeface="+mn-lt" charset="0"/>
                         <a:cs typeface="+mn-lt" charset="0"/>
@@ -5783,7 +5741,7 @@
                   </a:tcPr>
                 </a:tc>
               </a:tr>
-              <a:tr h="475488">
+              <a:tr h="457200">
                 <a:tc>
                   <a:txBody>
                     <a:bodyPr/>
@@ -5793,7 +5751,7 @@
                         <a:buNone/>
                       </a:pPr>
                       <a:r>
-                        <a:rPr lang="en-US" sz="1250" dirty="0">
+                        <a:rPr lang="en-US" sz="1300" dirty="0">
                           <a:solidFill>
                             <a:srgbClr val="141A22"/>
                           </a:solidFill>
@@ -5803,7 +5761,7 @@
                         </a:rPr>
                         <a:t>Route to the right approver from UC ownership or tags</a:t>
                       </a:r>
-                      <a:endParaRPr lang="en-US" sz="1250" dirty="0">
+                      <a:endParaRPr lang="en-US" sz="1300" dirty="0">
                         <a:latin typeface="+mn-lt" charset="0"/>
                         <a:ea typeface="+mn-lt" charset="0"/>
                         <a:cs typeface="+mn-lt" charset="0"/>
@@ -5861,7 +5819,7 @@
                         <a:buNone/>
                       </a:pPr>
                       <a:r>
-                        <a:rPr lang="en-US" sz="1250" dirty="0">
+                        <a:rPr lang="en-US" sz="1300" dirty="0">
                           <a:solidFill>
                             <a:srgbClr val="141A22"/>
                           </a:solidFill>
@@ -5871,7 +5829,7 @@
                         </a:rPr>
                         <a:t>Approver read from the data_owner tag at request time; two owners live tonight</a:t>
                       </a:r>
-                      <a:endParaRPr lang="en-US" sz="1250" dirty="0">
+                      <a:endParaRPr lang="en-US" sz="1300" dirty="0">
                         <a:latin typeface="+mn-lt" charset="0"/>
                         <a:ea typeface="+mn-lt" charset="0"/>
                         <a:cs typeface="+mn-lt" charset="0"/>
@@ -5929,7 +5887,7 @@
                         <a:buNone/>
                       </a:pPr>
                       <a:r>
-                        <a:rPr lang="en-US" sz="1250" b="1" dirty="0">
+                        <a:rPr lang="en-US" sz="1300" b="1" dirty="0">
                           <a:solidFill>
                             <a:srgbClr val="1B8A4C"/>
                           </a:solidFill>
@@ -5939,7 +5897,7 @@
                         </a:rPr>
                         <a:t>Done</a:t>
                       </a:r>
-                      <a:endParaRPr lang="en-US" sz="1250" dirty="0">
+                      <a:endParaRPr lang="en-US" sz="1300" dirty="0">
                         <a:latin typeface="+mn-lt" charset="0"/>
                         <a:ea typeface="+mn-lt" charset="0"/>
                         <a:cs typeface="+mn-lt" charset="0"/>
@@ -5989,7 +5947,7 @@
                   </a:tcPr>
                 </a:tc>
               </a:tr>
-              <a:tr h="475488">
+              <a:tr h="457200">
                 <a:tc>
                   <a:txBody>
                     <a:bodyPr/>
@@ -5999,7 +5957,7 @@
                         <a:buNone/>
                       </a:pPr>
                       <a:r>
-                        <a:rPr lang="en-US" sz="1250" dirty="0">
+                        <a:rPr lang="en-US" sz="1300" dirty="0">
                           <a:solidFill>
                             <a:srgbClr val="141A22"/>
                           </a:solidFill>
@@ -6009,7 +5967,7 @@
                         </a:rPr>
                         <a:t>Approve applies a real UC grant and informs the requester; reject blocks and says why</a:t>
                       </a:r>
-                      <a:endParaRPr lang="en-US" sz="1250" dirty="0">
+                      <a:endParaRPr lang="en-US" sz="1300" dirty="0">
                         <a:latin typeface="+mn-lt" charset="0"/>
                         <a:ea typeface="+mn-lt" charset="0"/>
                         <a:cs typeface="+mn-lt" charset="0"/>
@@ -6067,7 +6025,7 @@
                         <a:buNone/>
                       </a:pPr>
                       <a:r>
-                        <a:rPr lang="en-US" sz="1250" dirty="0">
+                        <a:rPr lang="en-US" sz="1300" dirty="0">
                           <a:solidFill>
                             <a:srgbClr val="141A22"/>
                           </a:solidFill>
@@ -6077,7 +6035,7 @@
                         </a:rPr>
                         <a:t>GRANT SELECT in Unity Catalog; status and the owner's note shown in-app; revoke keeps the record</a:t>
                       </a:r>
-                      <a:endParaRPr lang="en-US" sz="1250" dirty="0">
+                      <a:endParaRPr lang="en-US" sz="1300" dirty="0">
                         <a:latin typeface="+mn-lt" charset="0"/>
                         <a:ea typeface="+mn-lt" charset="0"/>
                         <a:cs typeface="+mn-lt" charset="0"/>
@@ -6135,7 +6093,7 @@
                         <a:buNone/>
                       </a:pPr>
                       <a:r>
-                        <a:rPr lang="en-US" sz="1250" b="1" dirty="0">
+                        <a:rPr lang="en-US" sz="1300" b="1" dirty="0">
                           <a:solidFill>
                             <a:srgbClr val="1B8A4C"/>
                           </a:solidFill>
@@ -6145,7 +6103,7 @@
                         </a:rPr>
                         <a:t>Done</a:t>
                       </a:r>
-                      <a:endParaRPr lang="en-US" sz="1250" dirty="0">
+                      <a:endParaRPr lang="en-US" sz="1300" dirty="0">
                         <a:latin typeface="+mn-lt" charset="0"/>
                         <a:ea typeface="+mn-lt" charset="0"/>
                         <a:cs typeface="+mn-lt" charset="0"/>
@@ -6195,7 +6153,7 @@
                   </a:tcPr>
                 </a:tc>
               </a:tr>
-              <a:tr h="475488">
+              <a:tr h="457200">
                 <a:tc>
                   <a:txBody>
                     <a:bodyPr/>
@@ -6205,7 +6163,7 @@
                         <a:buNone/>
                       </a:pPr>
                       <a:r>
-                        <a:rPr lang="en-US" sz="1250" dirty="0">
+                        <a:rPr lang="en-US" sz="1300" dirty="0">
                           <a:solidFill>
                             <a:srgbClr val="141A22"/>
                           </a:solidFill>
@@ -6215,7 +6173,7 @@
                         </a:rPr>
                         <a:t>Audit trail in a Delta table: who, what, when, outcome</a:t>
                       </a:r>
-                      <a:endParaRPr lang="en-US" sz="1250" dirty="0">
+                      <a:endParaRPr lang="en-US" sz="1300" dirty="0">
                         <a:latin typeface="+mn-lt" charset="0"/>
                         <a:ea typeface="+mn-lt" charset="0"/>
                         <a:cs typeface="+mn-lt" charset="0"/>
@@ -6273,7 +6231,7 @@
                         <a:buNone/>
                       </a:pPr>
                       <a:r>
-                        <a:rPr lang="en-US" sz="1250" dirty="0">
+                        <a:rPr lang="en-US" sz="1300" dirty="0">
                           <a:solidFill>
                             <a:srgbClr val="141A22"/>
                           </a:solidFill>
@@ -6283,7 +6241,7 @@
                         </a:rPr>
                         <a:t>access_requests is the queue and the receipt; Genie answers questions on it</a:t>
                       </a:r>
-                      <a:endParaRPr lang="en-US" sz="1250" dirty="0">
+                      <a:endParaRPr lang="en-US" sz="1300" dirty="0">
                         <a:latin typeface="+mn-lt" charset="0"/>
                         <a:ea typeface="+mn-lt" charset="0"/>
                         <a:cs typeface="+mn-lt" charset="0"/>
@@ -6341,7 +6299,7 @@
                         <a:buNone/>
                       </a:pPr>
                       <a:r>
-                        <a:rPr lang="en-US" sz="1250" b="1" dirty="0">
+                        <a:rPr lang="en-US" sz="1300" b="1" dirty="0">
                           <a:solidFill>
                             <a:srgbClr val="1B8A4C"/>
                           </a:solidFill>
@@ -6351,7 +6309,7 @@
                         </a:rPr>
                         <a:t>Done</a:t>
                       </a:r>
-                      <a:endParaRPr lang="en-US" sz="1250" dirty="0">
+                      <a:endParaRPr lang="en-US" sz="1300" dirty="0">
                         <a:latin typeface="+mn-lt" charset="0"/>
                         <a:ea typeface="+mn-lt" charset="0"/>
                         <a:cs typeface="+mn-lt" charset="0"/>
@@ -6401,7 +6359,7 @@
                   </a:tcPr>
                 </a:tc>
               </a:tr>
-              <a:tr h="475488">
+              <a:tr h="457200">
                 <a:tc>
                   <a:txBody>
                     <a:bodyPr/>
@@ -6411,7 +6369,7 @@
                         <a:buNone/>
                       </a:pPr>
                       <a:r>
-                        <a:rPr lang="en-US" sz="1250" dirty="0">
+                        <a:rPr lang="en-US" sz="1300" dirty="0">
                           <a:solidFill>
                             <a:srgbClr val="141A22"/>
                           </a:solidFill>
@@ -6421,7 +6379,7 @@
                         </a:rPr>
                         <a:t>Scope: tables only, one approver per asset, in-app queue</a:t>
                       </a:r>
-                      <a:endParaRPr lang="en-US" sz="1250" dirty="0">
+                      <a:endParaRPr lang="en-US" sz="1300" dirty="0">
                         <a:latin typeface="+mn-lt" charset="0"/>
                         <a:ea typeface="+mn-lt" charset="0"/>
                         <a:cs typeface="+mn-lt" charset="0"/>
@@ -6479,7 +6437,7 @@
                         <a:buNone/>
                       </a:pPr>
                       <a:r>
-                        <a:rPr lang="en-US" sz="1250" dirty="0">
+                        <a:rPr lang="en-US" sz="1300" dirty="0">
                           <a:solidFill>
                             <a:srgbClr val="141A22"/>
                           </a:solidFill>
@@ -6489,7 +6447,7 @@
                         </a:rPr>
                         <a:t>Exactly that, plus views as products</a:t>
                       </a:r>
-                      <a:endParaRPr lang="en-US" sz="1250" dirty="0">
+                      <a:endParaRPr lang="en-US" sz="1300" dirty="0">
                         <a:latin typeface="+mn-lt" charset="0"/>
                         <a:ea typeface="+mn-lt" charset="0"/>
                         <a:cs typeface="+mn-lt" charset="0"/>
@@ -6547,7 +6505,7 @@
                         <a:buNone/>
                       </a:pPr>
                       <a:r>
-                        <a:rPr lang="en-US" sz="1250" b="1" dirty="0">
+                        <a:rPr lang="en-US" sz="1300" b="1" dirty="0">
                           <a:solidFill>
                             <a:srgbClr val="1B8A4C"/>
                           </a:solidFill>
@@ -6557,7 +6515,7 @@
                         </a:rPr>
                         <a:t>Done</a:t>
                       </a:r>
-                      <a:endParaRPr lang="en-US" sz="1250" dirty="0">
+                      <a:endParaRPr lang="en-US" sz="1300" dirty="0">
                         <a:latin typeface="+mn-lt" charset="0"/>
                         <a:ea typeface="+mn-lt" charset="0"/>
                         <a:cs typeface="+mn-lt" charset="0"/>
@@ -6607,7 +6565,7 @@
                   </a:tcPr>
                 </a:tc>
               </a:tr>
-              <a:tr h="475488">
+              <a:tr h="457200">
                 <a:tc>
                   <a:txBody>
                     <a:bodyPr/>
@@ -6617,7 +6575,7 @@
                         <a:buNone/>
                       </a:pPr>
                       <a:r>
-                        <a:rPr lang="en-US" sz="1250" dirty="0">
+                        <a:rPr lang="en-US" sz="1300" dirty="0">
                           <a:solidFill>
                             <a:srgbClr val="141A22"/>
                           </a:solidFill>
@@ -6627,7 +6585,7 @@
                         </a:rPr>
                         <a:t>Stretch: Teams or email, time-boxed access</a:t>
                       </a:r>
-                      <a:endParaRPr lang="en-US" sz="1250" dirty="0">
+                      <a:endParaRPr lang="en-US" sz="1300" dirty="0">
                         <a:latin typeface="+mn-lt" charset="0"/>
                         <a:ea typeface="+mn-lt" charset="0"/>
                         <a:cs typeface="+mn-lt" charset="0"/>
@@ -6685,7 +6643,7 @@
                         <a:buNone/>
                       </a:pPr>
                       <a:r>
-                        <a:rPr lang="en-US" sz="1250" dirty="0">
+                        <a:rPr lang="en-US" sz="1300" dirty="0">
                           <a:solidFill>
                             <a:srgbClr val="141A22"/>
                           </a:solidFill>
@@ -6695,7 +6653,7 @@
                         </a:rPr>
                         <a:t>Next: expiring grants and notifications (slide 8)</a:t>
                       </a:r>
-                      <a:endParaRPr lang="en-US" sz="1250" dirty="0">
+                      <a:endParaRPr lang="en-US" sz="1300" dirty="0">
                         <a:latin typeface="+mn-lt" charset="0"/>
                         <a:ea typeface="+mn-lt" charset="0"/>
                         <a:cs typeface="+mn-lt" charset="0"/>
@@ -6753,7 +6711,7 @@
                         <a:buNone/>
                       </a:pPr>
                       <a:r>
-                        <a:rPr lang="en-US" sz="1250" b="1" dirty="0">
+                        <a:rPr lang="en-US" sz="1300" b="1" dirty="0">
                           <a:solidFill>
                             <a:srgbClr val="6B7280"/>
                           </a:solidFill>
@@ -6763,7 +6721,7 @@
                         </a:rPr>
                         <a:t>Next</a:t>
                       </a:r>
-                      <a:endParaRPr lang="en-US" sz="1250" dirty="0">
+                      <a:endParaRPr lang="en-US" sz="1300" dirty="0">
                         <a:latin typeface="+mn-lt" charset="0"/>
                         <a:ea typeface="+mn-lt" charset="0"/>
                         <a:cs typeface="+mn-lt" charset="0"/>
@@ -6825,12 +6783,12 @@
         </p:nvSpPr>
         <p:spPr>
           <a:xfrm>
-            <a:off x="822960" y="4983480"/>
-            <a:ext cx="2029968" cy="1188720"/>
+            <a:off x="822960" y="5440680"/>
+            <a:ext cx="2029968" cy="896112"/>
           </a:xfrm>
           <a:prstGeom prst="roundRect">
             <a:avLst>
-              <a:gd name="adj" fmla="val 9231"/>
+              <a:gd name="adj" fmla="val 12245"/>
             </a:avLst>
           </a:prstGeom>
           <a:solidFill>
@@ -6852,8 +6810,8 @@
         </p:nvSpPr>
         <p:spPr>
           <a:xfrm>
-            <a:off x="987552" y="5074920"/>
-            <a:ext cx="1737360" cy="320040"/>
+            <a:off x="987552" y="5486400"/>
+            <a:ext cx="1737360" cy="292608"/>
           </a:xfrm>
           <a:prstGeom prst="rect">
             <a:avLst/>
@@ -6869,14 +6827,14 @@
               <a:buNone/>
             </a:pPr>
             <a:r>
-              <a:rPr lang="en-US" sz="1250" b="1" dirty="0">
+              <a:rPr lang="en-US" sz="1300" b="1" dirty="0">
                 <a:solidFill>
                   <a:srgbClr val="3451D1"/>
                 </a:solidFill>
               </a:rPr>
               <a:t>Governance 25%</a:t>
             </a:r>
-            <a:endParaRPr lang="en-US" sz="1250" dirty="0"/>
+            <a:endParaRPr lang="en-US" sz="1300" dirty="0"/>
           </a:p>
         </p:txBody>
       </p:sp>
@@ -6888,8 +6846,8 @@
         </p:nvSpPr>
         <p:spPr>
           <a:xfrm>
-            <a:off x="987552" y="5394960"/>
-            <a:ext cx="1737360" cy="731520"/>
+            <a:off x="987552" y="5779008"/>
+            <a:ext cx="1737360" cy="530352"/>
           </a:xfrm>
           <a:prstGeom prst="rect">
             <a:avLst/>
@@ -6905,14 +6863,14 @@
               <a:buNone/>
             </a:pPr>
             <a:r>
-              <a:rPr lang="en-US" sz="1100" dirty="0">
+              <a:rPr lang="en-US" sz="1150" dirty="0">
                 <a:solidFill>
                   <a:srgbClr val="141A22"/>
                 </a:solidFill>
               </a:rPr>
               <a:t>Real grant, owner-only, nothing hidden</a:t>
             </a:r>
-            <a:endParaRPr lang="en-US" sz="1100" dirty="0"/>
+            <a:endParaRPr lang="en-US" sz="1150" dirty="0"/>
           </a:p>
         </p:txBody>
       </p:sp>
@@ -6924,12 +6882,12 @@
         </p:nvSpPr>
         <p:spPr>
           <a:xfrm>
-            <a:off x="2962656" y="4983480"/>
-            <a:ext cx="2029968" cy="1188720"/>
+            <a:off x="2962656" y="5440680"/>
+            <a:ext cx="2029968" cy="896112"/>
           </a:xfrm>
           <a:prstGeom prst="roundRect">
             <a:avLst>
-              <a:gd name="adj" fmla="val 9231"/>
+              <a:gd name="adj" fmla="val 12245"/>
             </a:avLst>
           </a:prstGeom>
           <a:solidFill>
@@ -6951,8 +6909,8 @@
         </p:nvSpPr>
         <p:spPr>
           <a:xfrm>
-            <a:off x="3127248" y="5074920"/>
-            <a:ext cx="1737360" cy="320040"/>
+            <a:off x="3127248" y="5486400"/>
+            <a:ext cx="1737360" cy="292608"/>
           </a:xfrm>
           <a:prstGeom prst="rect">
             <a:avLst/>
@@ -6968,14 +6926,14 @@
               <a:buNone/>
             </a:pPr>
             <a:r>
-              <a:rPr lang="en-US" sz="1250" b="1" dirty="0">
+              <a:rPr lang="en-US" sz="1300" b="1" dirty="0">
                 <a:solidFill>
                   <a:srgbClr val="3451D1"/>
                 </a:solidFill>
               </a:rPr>
               <a:t>Reusability 25%</a:t>
             </a:r>
-            <a:endParaRPr lang="en-US" sz="1250" dirty="0"/>
+            <a:endParaRPr lang="en-US" sz="1300" dirty="0"/>
           </a:p>
         </p:txBody>
       </p:sp>
@@ -6987,8 +6945,8 @@
         </p:nvSpPr>
         <p:spPr>
           <a:xfrm>
-            <a:off x="3127248" y="5394960"/>
-            <a:ext cx="1737360" cy="731520"/>
+            <a:off x="3127248" y="5779008"/>
+            <a:ext cx="1737360" cy="530352"/>
           </a:xfrm>
           <a:prstGeom prst="rect">
             <a:avLst/>
@@ -7004,14 +6962,14 @@
               <a:buNone/>
             </a:pPr>
             <a:r>
-              <a:rPr lang="en-US" sz="1100" dirty="0">
+              <a:rPr lang="en-US" sz="1150" dirty="0">
                 <a:solidFill>
                   <a:srgbClr val="141A22"/>
                 </a:solidFill>
               </a:rPr>
               <a:t>Tag a table, it appears; no code</a:t>
             </a:r>
-            <a:endParaRPr lang="en-US" sz="1100" dirty="0"/>
+            <a:endParaRPr lang="en-US" sz="1150" dirty="0"/>
           </a:p>
         </p:txBody>
       </p:sp>
@@ -7023,12 +6981,12 @@
         </p:nvSpPr>
         <p:spPr>
           <a:xfrm>
-            <a:off x="5102352" y="4983480"/>
-            <a:ext cx="2029968" cy="1188720"/>
+            <a:off x="5102352" y="5440680"/>
+            <a:ext cx="2029968" cy="896112"/>
           </a:xfrm>
           <a:prstGeom prst="roundRect">
             <a:avLst>
-              <a:gd name="adj" fmla="val 9231"/>
+              <a:gd name="adj" fmla="val 12245"/>
             </a:avLst>
           </a:prstGeom>
           <a:solidFill>
@@ -7050,8 +7008,8 @@
         </p:nvSpPr>
         <p:spPr>
           <a:xfrm>
-            <a:off x="5266944" y="5074920"/>
-            <a:ext cx="1737360" cy="320040"/>
+            <a:off x="5266944" y="5486400"/>
+            <a:ext cx="1737360" cy="292608"/>
           </a:xfrm>
           <a:prstGeom prst="rect">
             <a:avLst/>
@@ -7067,14 +7025,14 @@
               <a:buNone/>
             </a:pPr>
             <a:r>
-              <a:rPr lang="en-US" sz="1250" b="1" dirty="0">
+              <a:rPr lang="en-US" sz="1300" b="1" dirty="0">
                 <a:solidFill>
                   <a:srgbClr val="3451D1"/>
                 </a:solidFill>
               </a:rPr>
               <a:t>Self-service 25%</a:t>
             </a:r>
-            <a:endParaRPr lang="en-US" sz="1250" dirty="0"/>
+            <a:endParaRPr lang="en-US" sz="1300" dirty="0"/>
           </a:p>
         </p:txBody>
       </p:sp>
@@ -7086,8 +7044,8 @@
         </p:nvSpPr>
         <p:spPr>
           <a:xfrm>
-            <a:off x="5266944" y="5394960"/>
-            <a:ext cx="1737360" cy="731520"/>
+            <a:off x="5266944" y="5779008"/>
+            <a:ext cx="1737360" cy="530352"/>
           </a:xfrm>
           <a:prstGeom prst="rect">
             <a:avLst/>
@@ -7103,14 +7061,14 @@
               <a:buNone/>
             </a:pPr>
             <a:r>
-              <a:rPr lang="en-US" sz="1100" dirty="0">
+              <a:rPr lang="en-US" sz="1150" dirty="0">
                 <a:solidFill>
                   <a:srgbClr val="141A22"/>
                 </a:solidFill>
               </a:rPr>
               <a:t>No ticket: ask, see status, download</a:t>
             </a:r>
-            <a:endParaRPr lang="en-US" sz="1100" dirty="0"/>
+            <a:endParaRPr lang="en-US" sz="1150" dirty="0"/>
           </a:p>
         </p:txBody>
       </p:sp>
@@ -7122,12 +7080,12 @@
         </p:nvSpPr>
         <p:spPr>
           <a:xfrm>
-            <a:off x="7242048" y="4983480"/>
-            <a:ext cx="2029968" cy="1188720"/>
+            <a:off x="7242048" y="5440680"/>
+            <a:ext cx="2029968" cy="896112"/>
           </a:xfrm>
           <a:prstGeom prst="roundRect">
             <a:avLst>
-              <a:gd name="adj" fmla="val 9231"/>
+              <a:gd name="adj" fmla="val 12245"/>
             </a:avLst>
           </a:prstGeom>
           <a:solidFill>
@@ -7149,8 +7107,8 @@
         </p:nvSpPr>
         <p:spPr>
           <a:xfrm>
-            <a:off x="7406640" y="5074920"/>
-            <a:ext cx="1737360" cy="320040"/>
+            <a:off x="7406640" y="5486400"/>
+            <a:ext cx="1737360" cy="292608"/>
           </a:xfrm>
           <a:prstGeom prst="rect">
             <a:avLst/>
@@ -7166,14 +7124,14 @@
               <a:buNone/>
             </a:pPr>
             <a:r>
-              <a:rPr lang="en-US" sz="1250" b="1" dirty="0">
+              <a:rPr lang="en-US" sz="1300" b="1" dirty="0">
                 <a:solidFill>
                   <a:srgbClr val="3451D1"/>
                 </a:solidFill>
               </a:rPr>
               <a:t>Polish 15%</a:t>
             </a:r>
-            <a:endParaRPr lang="en-US" sz="1250" dirty="0"/>
+            <a:endParaRPr lang="en-US" sz="1300" dirty="0"/>
           </a:p>
         </p:txBody>
       </p:sp>
@@ -7185,8 +7143,8 @@
         </p:nvSpPr>
         <p:spPr>
           <a:xfrm>
-            <a:off x="7406640" y="5394960"/>
-            <a:ext cx="1737360" cy="731520"/>
+            <a:off x="7406640" y="5779008"/>
+            <a:ext cx="1737360" cy="530352"/>
           </a:xfrm>
           <a:prstGeom prst="rect">
             <a:avLst/>
@@ -7202,14 +7160,14 @@
               <a:buNone/>
             </a:pPr>
             <a:r>
-              <a:rPr lang="en-US" sz="1100" dirty="0">
+              <a:rPr lang="en-US" sz="1150" dirty="0">
                 <a:solidFill>
                   <a:srgbClr val="141A22"/>
                 </a:solidFill>
               </a:rPr>
               <a:t>One accent, one card, one reason</a:t>
             </a:r>
-            <a:endParaRPr lang="en-US" sz="1100" dirty="0"/>
+            <a:endParaRPr lang="en-US" sz="1150" dirty="0"/>
           </a:p>
         </p:txBody>
       </p:sp>
@@ -7221,12 +7179,12 @@
         </p:nvSpPr>
         <p:spPr>
           <a:xfrm>
-            <a:off x="9381744" y="4983480"/>
-            <a:ext cx="2029968" cy="1188720"/>
+            <a:off x="9381744" y="5440680"/>
+            <a:ext cx="2029968" cy="896112"/>
           </a:xfrm>
           <a:prstGeom prst="roundRect">
             <a:avLst>
-              <a:gd name="adj" fmla="val 9231"/>
+              <a:gd name="adj" fmla="val 12245"/>
             </a:avLst>
           </a:prstGeom>
           <a:solidFill>
@@ -7248,8 +7206,8 @@
         </p:nvSpPr>
         <p:spPr>
           <a:xfrm>
-            <a:off x="9546336" y="5074920"/>
-            <a:ext cx="1737360" cy="320040"/>
+            <a:off x="9546336" y="5486400"/>
+            <a:ext cx="1737360" cy="292608"/>
           </a:xfrm>
           <a:prstGeom prst="rect">
             <a:avLst/>
@@ -7265,14 +7223,14 @@
               <a:buNone/>
             </a:pPr>
             <a:r>
-              <a:rPr lang="en-US" sz="1250" b="1" dirty="0">
+              <a:rPr lang="en-US" sz="1300" b="1" dirty="0">
                 <a:solidFill>
                   <a:srgbClr val="3451D1"/>
                 </a:solidFill>
               </a:rPr>
               <a:t>Innovation 10%</a:t>
             </a:r>
-            <a:endParaRPr lang="en-US" sz="1250" dirty="0"/>
+            <a:endParaRPr lang="en-US" sz="1300" dirty="0"/>
           </a:p>
         </p:txBody>
       </p:sp>
@@ -7284,8 +7242,8 @@
         </p:nvSpPr>
         <p:spPr>
           <a:xfrm>
-            <a:off x="9546336" y="5394960"/>
-            <a:ext cx="1737360" cy="731520"/>
+            <a:off x="9546336" y="5779008"/>
+            <a:ext cx="1737360" cy="530352"/>
           </a:xfrm>
           <a:prstGeom prst="rect">
             <a:avLst/>
@@ -7301,14 +7259,14 @@
               <a:buNone/>
             </a:pPr>
             <a:r>
-              <a:rPr lang="en-US" sz="1100" dirty="0">
+              <a:rPr lang="en-US" sz="1150" dirty="0">
                 <a:solidFill>
                   <a:srgbClr val="141A22"/>
                 </a:solidFill>
               </a:rPr>
               <a:t>Genie on the audit trail, ai_classify on reasons</a:t>
             </a:r>
-            <a:endParaRPr lang="en-US" sz="1100" dirty="0"/>
+            <a:endParaRPr lang="en-US" sz="1150" dirty="0"/>
           </a:p>
         </p:txBody>
       </p:sp>
@@ -7472,14 +7430,14 @@
               <a:buNone/>
             </a:pPr>
             <a:r>
-              <a:rPr lang="en-US" sz="1800" b="1" dirty="0">
+              <a:rPr lang="en-US" sz="2000" b="1" dirty="0">
                 <a:solidFill>
                   <a:srgbClr val="141A22"/>
                 </a:solidFill>
               </a:rPr>
               <a:t>Expiring access</a:t>
             </a:r>
-            <a:endParaRPr lang="en-US" sz="1800" dirty="0"/>
+            <a:endParaRPr lang="en-US" sz="2000" dirty="0"/>
           </a:p>
         </p:txBody>
       </p:sp>
@@ -7508,14 +7466,14 @@
               <a:buNone/>
             </a:pPr>
             <a:r>
-              <a:rPr lang="en-US" sz="1500" dirty="0">
+              <a:rPr lang="en-US" sz="1700" dirty="0">
                 <a:solidFill>
                   <a:srgbClr val="141A22"/>
                 </a:solidFill>
               </a:rPr>
               <a:t>Grants with an end date and a scheduled revoke, so entitlements never outlive the project.</a:t>
             </a:r>
-            <a:endParaRPr lang="en-US" sz="1500" dirty="0"/>
+            <a:endParaRPr lang="en-US" sz="1700" dirty="0"/>
           </a:p>
         </p:txBody>
       </p:sp>
@@ -7571,14 +7529,14 @@
               <a:buNone/>
             </a:pPr>
             <a:r>
-              <a:rPr lang="en-US" sz="1800" b="1" dirty="0">
+              <a:rPr lang="en-US" sz="2000" b="1" dirty="0">
                 <a:solidFill>
                   <a:srgbClr val="141A22"/>
                 </a:solidFill>
               </a:rPr>
               <a:t>Notify the owner</a:t>
             </a:r>
-            <a:endParaRPr lang="en-US" sz="1800" dirty="0"/>
+            <a:endParaRPr lang="en-US" sz="2000" dirty="0"/>
           </a:p>
         </p:txBody>
       </p:sp>
@@ -7607,14 +7565,14 @@
               <a:buNone/>
             </a:pPr>
             <a:r>
-              <a:rPr lang="en-US" sz="1500" dirty="0">
+              <a:rPr lang="en-US" sz="1700" dirty="0">
                 <a:solidFill>
                   <a:srgbClr val="141A22"/>
                 </a:solidFill>
               </a:rPr>
               <a:t>Teams or email on request and on decision; the queue comes to you.</a:t>
             </a:r>
-            <a:endParaRPr lang="en-US" sz="1500" dirty="0"/>
+            <a:endParaRPr lang="en-US" sz="1700" dirty="0"/>
           </a:p>
         </p:txBody>
       </p:sp>
@@ -7670,14 +7628,14 @@
               <a:buNone/>
             </a:pPr>
             <a:r>
-              <a:rPr lang="en-US" sz="1800" b="1" dirty="0">
+              <a:rPr lang="en-US" sz="2000" b="1" dirty="0">
                 <a:solidFill>
                   <a:srgbClr val="141A22"/>
                 </a:solidFill>
               </a:rPr>
               <a:t>Chargeback</a:t>
             </a:r>
-            <a:endParaRPr lang="en-US" sz="1800" dirty="0"/>
+            <a:endParaRPr lang="en-US" sz="2000" dirty="0"/>
           </a:p>
         </p:txBody>
       </p:sp>
@@ -7706,14 +7664,14 @@
               <a:buNone/>
             </a:pPr>
             <a:r>
-              <a:rPr lang="en-US" sz="1500" dirty="0">
+              <a:rPr lang="en-US" sz="1700" dirty="0">
                 <a:solidFill>
                   <a:srgbClr val="141A22"/>
                 </a:solidFill>
               </a:rPr>
               <a:t>Licence spend by desk and cost centre, straight from the audit table.</a:t>
             </a:r>
-            <a:endParaRPr lang="en-US" sz="1500" dirty="0"/>
+            <a:endParaRPr lang="en-US" sz="1700" dirty="0"/>
           </a:p>
         </p:txBody>
       </p:sp>
@@ -7778,28 +7736,28 @@
               <a:buNone/>
             </a:pPr>
             <a:r>
-              <a:rPr lang="en-US" sz="1400" dirty="0">
+              <a:rPr lang="en-US" sz="1600" dirty="0">
                 <a:solidFill>
                   <a:srgbClr val="6B7280"/>
                 </a:solidFill>
               </a:rPr>
               <a:t>Jose and Malik, front end  ·  Younis and Patrick, data, governance and platform</a:t>
             </a:r>
-            <a:endParaRPr lang="en-US" sz="1400" dirty="0"/>
+            <a:endParaRPr lang="en-US" sz="1600" dirty="0"/>
           </a:p>
           <a:p>
             <a:pPr indent="0" marL="0">
               <a:buNone/>
             </a:pPr>
             <a:r>
-              <a:rPr lang="en-US" sz="1400" dirty="0">
+              <a:rPr lang="en-US" sz="1600" dirty="0">
                 <a:solidFill>
                   <a:srgbClr val="6B7280"/>
                 </a:solidFill>
               </a:rPr>
               <a:t>Databricks Apps, Unity Catalog, Genie, ai_classify. Built with Codex and Claude Code.</a:t>
             </a:r>
-            <a:endParaRPr lang="en-US" sz="1400" dirty="0"/>
+            <a:endParaRPr lang="en-US" sz="1600" dirty="0"/>
           </a:p>
         </p:txBody>
       </p:sp>
@@ -7828,14 +7786,14 @@
               <a:buNone/>
             </a:pPr>
             <a:r>
-              <a:rPr lang="en-US" sz="1400" dirty="0">
+              <a:rPr lang="en-US" sz="1600" dirty="0">
                 <a:solidFill>
                   <a:srgbClr val="3451D1"/>
                 </a:solidFill>
               </a:rPr>
               <a:t>github.com/younis-y/desk-data-access</a:t>
             </a:r>
-            <a:endParaRPr lang="en-US" sz="1400" dirty="0"/>
+            <a:endParaRPr lang="en-US" sz="1600" dirty="0"/>
           </a:p>
         </p:txBody>
       </p:sp>

</xml_diff>